<commit_message>
Slides: sd-13-026 re-exported with the current progress dot in red
Co-Authored-By: Claude Opus 5.5 <noreply@anthropic.com>
Claude-Session: https://claude.ai/code/session_01TQmrJYLm4GPgtXpQaEk7ey
</commit_message>
<xml_diff>
--- a/system-design-101/vi/lessons/sd-13-026/slides/sd-13-026.pptx
+++ b/system-design-101/vi/lessons/sd-13-026/slides/sd-13-026.pptx
@@ -4468,11 +4468,11 @@
             <a:avLst/>
           </a:prstGeom>
           <a:solidFill>
-            <a:srgbClr val="F3EEE3"/>
+            <a:srgbClr val="FF6A4D"/>
           </a:solidFill>
           <a:ln w="19050">
             <a:solidFill>
-              <a:srgbClr val="F3EEE3"/>
+              <a:srgbClr val="FF6A4D"/>
             </a:solidFill>
             <a:prstDash val="solid"/>
           </a:ln>
@@ -5263,11 +5263,11 @@
             <a:avLst/>
           </a:prstGeom>
           <a:solidFill>
-            <a:srgbClr val="14161C"/>
+            <a:srgbClr val="E8472B"/>
           </a:solidFill>
           <a:ln w="19050">
             <a:solidFill>
-              <a:srgbClr val="14161C"/>
+              <a:srgbClr val="E8472B"/>
             </a:solidFill>
             <a:prstDash val="solid"/>
           </a:ln>
@@ -6448,11 +6448,11 @@
             <a:avLst/>
           </a:prstGeom>
           <a:solidFill>
-            <a:srgbClr val="3DD6A0"/>
+            <a:srgbClr val="FF6A4D"/>
           </a:solidFill>
           <a:ln w="19050">
             <a:solidFill>
-              <a:srgbClr val="3DD6A0"/>
+              <a:srgbClr val="FF6A4D"/>
             </a:solidFill>
             <a:prstDash val="solid"/>
           </a:ln>
@@ -9386,11 +9386,11 @@
             <a:avLst/>
           </a:prstGeom>
           <a:solidFill>
-            <a:srgbClr val="7C93FF"/>
+            <a:srgbClr val="FF6A4D"/>
           </a:solidFill>
           <a:ln w="19050">
             <a:solidFill>
-              <a:srgbClr val="7C93FF"/>
+              <a:srgbClr val="FF6A4D"/>
             </a:solidFill>
             <a:prstDash val="solid"/>
           </a:ln>
@@ -10737,11 +10737,11 @@
             <a:avLst/>
           </a:prstGeom>
           <a:solidFill>
-            <a:srgbClr val="B45309"/>
+            <a:srgbClr val="E8472B"/>
           </a:solidFill>
           <a:ln w="19050">
             <a:solidFill>
-              <a:srgbClr val="B45309"/>
+              <a:srgbClr val="E8472B"/>
             </a:solidFill>
             <a:prstDash val="solid"/>
           </a:ln>
@@ -12258,11 +12258,11 @@
             <a:avLst/>
           </a:prstGeom>
           <a:solidFill>
-            <a:srgbClr val="F3EEE3"/>
+            <a:srgbClr val="FF6A4D"/>
           </a:solidFill>
           <a:ln w="19050">
             <a:solidFill>
-              <a:srgbClr val="F3EEE3"/>
+              <a:srgbClr val="FF6A4D"/>
             </a:solidFill>
             <a:prstDash val="solid"/>
           </a:ln>
@@ -13618,11 +13618,11 @@
             <a:avLst/>
           </a:prstGeom>
           <a:solidFill>
-            <a:srgbClr val="1F3FD1"/>
+            <a:srgbClr val="E8472B"/>
           </a:solidFill>
           <a:ln w="19050">
             <a:solidFill>
-              <a:srgbClr val="1F3FD1"/>
+              <a:srgbClr val="E8472B"/>
             </a:solidFill>
             <a:prstDash val="solid"/>
           </a:ln>
@@ -15453,11 +15453,11 @@
             <a:avLst/>
           </a:prstGeom>
           <a:solidFill>
-            <a:srgbClr val="14161C"/>
+            <a:srgbClr val="E8472B"/>
           </a:solidFill>
           <a:ln w="19050">
             <a:solidFill>
-              <a:srgbClr val="14161C"/>
+              <a:srgbClr val="E8472B"/>
             </a:solidFill>
             <a:prstDash val="solid"/>
           </a:ln>

</xml_diff>

<commit_message>
Slides: sd-13-026, sd-13-027 titles at 92/108 and the DevOps và CI/CD group on the cover
Co-Authored-By: Claude Opus 5.5 <noreply@anthropic.com>
Claude-Session: https://claude.ai/code/session_01TQmrJYLm4GPgtXpQaEk7ey
</commit_message>
<xml_diff>
--- a/system-design-101/vi/lessons/sd-13-026/slides/sd-13-026.pptx
+++ b/system-design-101/vi/lessons/sd-13-026/slides/sd-13-026.pptx
@@ -1794,8 +1794,8 @@
         </p:nvSpPr>
         <p:spPr>
           <a:xfrm>
-            <a:off x="914400" y="1524000"/>
-            <a:ext cx="8191500" cy="4191000"/>
+            <a:off x="914400" y="1333500"/>
+            <a:ext cx="8191500" cy="5905500"/>
           </a:xfrm>
           <a:prstGeom prst="rect">
             <a:avLst/>
@@ -1804,17 +1804,17 @@
           <a:ln/>
         </p:spPr>
         <p:txBody>
-          <a:bodyPr wrap="square" lIns="0" tIns="54483" rIns="0" bIns="-54483" rtlCol="0" anchor="t"/>
+          <a:bodyPr wrap="square" lIns="0" tIns="66866" rIns="0" bIns="-66866" rtlCol="0" anchor="t"/>
           <a:lstStyle/>
           <a:p>
             <a:pPr algn="l" indent="0" marL="0">
               <a:lnSpc>
-                <a:spcPts val="6996"/>
+                <a:spcPts val="8586"/>
               </a:lnSpc>
               <a:buNone/>
             </a:pPr>
             <a:r>
-              <a:rPr lang="en-US" sz="6600" dirty="0" spc="-2" kern="0">
+              <a:rPr lang="en-US" sz="8100" dirty="0" spc="0" kern="0">
                 <a:solidFill>
                   <a:srgbClr val="F3EEE3"/>
                 </a:solidFill>
@@ -1825,7 +1825,7 @@
               <a:t>Container</a:t>
             </a:r>
             <a:r>
-              <a:rPr lang="en-US" sz="6600" dirty="0" spc="-20" kern="0">
+              <a:rPr lang="en-US" sz="8100" dirty="0" spc="-23" kern="0">
                 <a:solidFill>
                   <a:srgbClr val="F3EEE3"/>
                 </a:solidFill>
@@ -1836,7 +1836,7 @@
               <a:t> Docker</a:t>
             </a:r>
             <a:r>
-              <a:rPr lang="en-US" sz="6600" dirty="0" spc="-5" kern="0">
+              <a:rPr lang="en-US" sz="8100" dirty="0" spc="-5" kern="0">
                 <a:solidFill>
                   <a:srgbClr val="F3EEE3"/>
                 </a:solidFill>
@@ -1847,7 +1847,7 @@
               <a:t> thoát</a:t>
             </a:r>
             <a:r>
-              <a:rPr lang="en-US" sz="6600" dirty="0" spc="-14" kern="0">
+              <a:rPr lang="en-US" sz="8100" dirty="0" spc="-16" kern="0">
                 <a:solidFill>
                   <a:srgbClr val="F3EEE3"/>
                 </a:solidFill>
@@ -1858,7 +1858,7 @@
               <a:t> ngay</a:t>
             </a:r>
             <a:r>
-              <a:rPr lang="en-US" sz="6600" dirty="0" spc="-7" kern="0">
+              <a:rPr lang="en-US" sz="8100" dirty="0" spc="-7" kern="0">
                 <a:solidFill>
                   <a:srgbClr val="F3EEE3"/>
                 </a:solidFill>
@@ -1869,7 +1869,7 @@
               <a:t> hoặc</a:t>
             </a:r>
             <a:r>
-              <a:rPr lang="en-US" sz="6600" dirty="0" spc="-27" kern="0">
+              <a:rPr lang="en-US" sz="8100" dirty="0" spc="-34" kern="0">
                 <a:solidFill>
                   <a:srgbClr val="F3EEE3"/>
                 </a:solidFill>
@@ -1880,7 +1880,7 @@
               <a:t> khởi</a:t>
             </a:r>
             <a:r>
-              <a:rPr lang="en-US" sz="6600" dirty="0" spc="10" kern="0">
+              <a:rPr lang="en-US" sz="8100" dirty="0" spc="13" kern="0">
                 <a:solidFill>
                   <a:srgbClr val="F3EEE3"/>
                 </a:solidFill>
@@ -1891,7 +1891,7 @@
               <a:t> động</a:t>
             </a:r>
             <a:r>
-              <a:rPr lang="en-US" sz="6600" dirty="0" spc="-3" kern="0">
+              <a:rPr lang="en-US" sz="8100" dirty="0" spc="-4" kern="0">
                 <a:solidFill>
                   <a:srgbClr val="F3EEE3"/>
                 </a:solidFill>
@@ -1902,7 +1902,7 @@
               <a:t> lại</a:t>
             </a:r>
             <a:r>
-              <a:rPr lang="en-US" sz="6600" dirty="0" spc="-1" kern="0">
+              <a:rPr lang="en-US" sz="8100" dirty="0" spc="-2" kern="0">
                 <a:solidFill>
                   <a:srgbClr val="F3EEE3"/>
                 </a:solidFill>
@@ -1913,7 +1913,7 @@
               <a:t> mãi:</a:t>
             </a:r>
             <a:r>
-              <a:rPr lang="en-US" sz="6600" dirty="0" spc="2" kern="0">
+              <a:rPr lang="en-US" sz="8100" dirty="0" spc="1" kern="0">
                 <a:solidFill>
                   <a:srgbClr val="F3EEE3"/>
                 </a:solidFill>
@@ -1924,7 +1924,7 @@
               <a:t> bốn</a:t>
             </a:r>
             <a:r>
-              <a:rPr lang="en-US" sz="6600" dirty="0" spc="0" kern="0">
+              <a:rPr lang="en-US" sz="8100" dirty="0" spc="2" kern="0">
                 <a:solidFill>
                   <a:srgbClr val="F3EEE3"/>
                 </a:solidFill>
@@ -1932,9 +1932,20 @@
                 <a:ea typeface="Bricolage Grotesque ExtraBold" pitchFamily="34" charset="-122"/>
                 <a:cs typeface="Bricolage Grotesque ExtraBold" pitchFamily="34" charset="-120"/>
               </a:rPr>
-              <a:t> manh mối</a:t>
-            </a:r>
-            <a:endParaRPr lang="en-US" sz="6600" dirty="0"/>
+              <a:t> manh</a:t>
+            </a:r>
+            <a:r>
+              <a:rPr lang="en-US" sz="8100" dirty="0" spc="-1" kern="0">
+                <a:solidFill>
+                  <a:srgbClr val="F3EEE3"/>
+                </a:solidFill>
+                <a:latin typeface="Bricolage Grotesque ExtraBold" pitchFamily="34" charset="0"/>
+                <a:ea typeface="Bricolage Grotesque ExtraBold" pitchFamily="34" charset="-122"/>
+                <a:cs typeface="Bricolage Grotesque ExtraBold" pitchFamily="34" charset="-120"/>
+              </a:rPr>
+              <a:t> mối</a:t>
+            </a:r>
+            <a:endParaRPr lang="en-US" sz="8100" dirty="0"/>
           </a:p>
         </p:txBody>
       </p:sp>
@@ -1946,7 +1957,7 @@
         </p:nvSpPr>
         <p:spPr>
           <a:xfrm>
-            <a:off x="914400" y="6286500"/>
+            <a:off x="914400" y="7429500"/>
             <a:ext cx="8191500" cy="1047750"/>
           </a:xfrm>
           <a:prstGeom prst="rect">
@@ -2115,7 +2126,7 @@
               <a:t> nhóm</a:t>
             </a:r>
             <a:r>
-              <a:rPr lang="en-US" sz="1650" dirty="0" spc="-3" kern="0">
+              <a:rPr lang="en-US" sz="1650" dirty="0" spc="-4" kern="0">
                 <a:solidFill>
                   <a:srgbClr val="9AA0B5"/>
                 </a:solidFill>
@@ -2123,10 +2134,10 @@
                 <a:ea typeface="Be Vietnam Pro" pitchFamily="34" charset="-122"/>
                 <a:cs typeface="Be Vietnam Pro" pitchFamily="34" charset="-120"/>
               </a:rPr>
-              <a:t> Quan</a:t>
-            </a:r>
-            <a:r>
-              <a:rPr lang="en-US" sz="1650" dirty="0" spc="-9" kern="0">
+              <a:t> DevOps</a:t>
+            </a:r>
+            <a:r>
+              <a:rPr lang="en-US" sz="1650" dirty="0" spc="-7" kern="0">
                 <a:solidFill>
                   <a:srgbClr val="9AA0B5"/>
                 </a:solidFill>
@@ -2134,7 +2145,7 @@
                 <a:ea typeface="Be Vietnam Pro" pitchFamily="34" charset="-122"/>
                 <a:cs typeface="Be Vietnam Pro" pitchFamily="34" charset="-120"/>
               </a:rPr>
-              <a:t> sát</a:t>
+              <a:t> và</a:t>
             </a:r>
             <a:r>
               <a:rPr lang="en-US" sz="1650" dirty="0" spc="3" kern="0">
@@ -2145,18 +2156,7 @@
                 <a:ea typeface="Be Vietnam Pro" pitchFamily="34" charset="-122"/>
                 <a:cs typeface="Be Vietnam Pro" pitchFamily="34" charset="-120"/>
               </a:rPr>
-              <a:t> hệ</a:t>
-            </a:r>
-            <a:r>
-              <a:rPr lang="en-US" sz="1650" dirty="0" spc="1" kern="0">
-                <a:solidFill>
-                  <a:srgbClr val="9AA0B5"/>
-                </a:solidFill>
-                <a:latin typeface="Be Vietnam Pro" pitchFamily="34" charset="0"/>
-                <a:ea typeface="Be Vietnam Pro" pitchFamily="34" charset="-122"/>
-                <a:cs typeface="Be Vietnam Pro" pitchFamily="34" charset="-120"/>
-              </a:rPr>
-              <a:t> thống</a:t>
+              <a:t> CI/CD</a:t>
             </a:r>
             <a:endParaRPr lang="en-US" sz="1650" dirty="0"/>
           </a:p>
@@ -3048,8 +3048,8 @@
         </p:nvSpPr>
         <p:spPr>
           <a:xfrm>
-            <a:off x="914400" y="1428750"/>
-            <a:ext cx="16192500" cy="952500"/>
+            <a:off x="914400" y="1219200"/>
+            <a:ext cx="16459200" cy="1047750"/>
           </a:xfrm>
           <a:prstGeom prst="rect">
             <a:avLst/>
@@ -3058,17 +3058,17 @@
           <a:ln/>
         </p:spPr>
         <p:txBody>
-          <a:bodyPr wrap="square" lIns="0" tIns="30480" rIns="0" bIns="-30480" rtlCol="0" anchor="t"/>
+          <a:bodyPr wrap="square" lIns="0" tIns="43815" rIns="0" bIns="-43815" rtlCol="0" anchor="t"/>
           <a:lstStyle/>
           <a:p>
             <a:pPr algn="l" indent="0" marL="0">
               <a:lnSpc>
-                <a:spcPts val="5280"/>
+                <a:spcPts val="7590"/>
               </a:lnSpc>
               <a:buNone/>
             </a:pPr>
             <a:r>
-              <a:rPr lang="en-US" sz="4800" dirty="0" spc="0" kern="0">
+              <a:rPr lang="en-US" sz="6900" dirty="0" spc="-4" kern="0">
                 <a:solidFill>
                   <a:srgbClr val="F3EEE3"/>
                 </a:solidFill>
@@ -3079,7 +3079,7 @@
               <a:t>Ba</a:t>
             </a:r>
             <a:r>
-              <a:rPr lang="en-US" sz="4800" dirty="0" spc="3" kern="0">
+              <a:rPr lang="en-US" sz="6900" dirty="0" spc="-1" kern="0">
                 <a:solidFill>
                   <a:srgbClr val="F3EEE3"/>
                 </a:solidFill>
@@ -3090,7 +3090,7 @@
               <a:t> từ</a:t>
             </a:r>
             <a:r>
-              <a:rPr lang="en-US" sz="4800" dirty="0" spc="0" kern="0">
+              <a:rPr lang="en-US" sz="6900" dirty="0" spc="1" kern="0">
                 <a:solidFill>
                   <a:srgbClr val="F3EEE3"/>
                 </a:solidFill>
@@ -3101,7 +3101,7 @@
               <a:t> viết</a:t>
             </a:r>
             <a:r>
-              <a:rPr lang="en-US" sz="4800" dirty="0" spc="-4" kern="0">
+              <a:rPr lang="en-US" sz="6900" dirty="0" spc="-5" kern="0">
                 <a:solidFill>
                   <a:srgbClr val="F3EEE3"/>
                 </a:solidFill>
@@ -3112,7 +3112,7 @@
               <a:t> tắt</a:t>
             </a:r>
             <a:r>
-              <a:rPr lang="en-US" sz="4800" dirty="0" spc="-11" kern="0">
+              <a:rPr lang="en-US" sz="6900" dirty="0" spc="-13" kern="0">
                 <a:solidFill>
                   <a:srgbClr val="F3EEE3"/>
                 </a:solidFill>
@@ -3123,7 +3123,7 @@
               <a:t> trong</a:t>
             </a:r>
             <a:r>
-              <a:rPr lang="en-US" sz="4800" dirty="0" spc="-4" kern="0">
+              <a:rPr lang="en-US" sz="6900" dirty="0" spc="-4" kern="0">
                 <a:solidFill>
                   <a:srgbClr val="F3EEE3"/>
                 </a:solidFill>
@@ -3133,7 +3133,7 @@
               </a:rPr>
               <a:t> bài</a:t>
             </a:r>
-            <a:endParaRPr lang="en-US" sz="4800" dirty="0"/>
+            <a:endParaRPr lang="en-US" sz="6900" dirty="0"/>
           </a:p>
         </p:txBody>
       </p:sp>
@@ -5627,8 +5627,8 @@
         </p:nvSpPr>
         <p:spPr>
           <a:xfrm>
-            <a:off x="914400" y="1428750"/>
-            <a:ext cx="16192500" cy="1143000"/>
+            <a:off x="914400" y="1219200"/>
+            <a:ext cx="16459200" cy="1047750"/>
           </a:xfrm>
           <a:prstGeom prst="rect">
             <a:avLst/>
@@ -5637,17 +5637,17 @@
           <a:ln/>
         </p:spPr>
         <p:txBody>
-          <a:bodyPr wrap="square" lIns="0" tIns="30480" rIns="0" bIns="-30480" rtlCol="0" anchor="t"/>
+          <a:bodyPr wrap="square" lIns="0" tIns="43815" rIns="0" bIns="-43815" rtlCol="0" anchor="t"/>
           <a:lstStyle/>
           <a:p>
             <a:pPr algn="l" indent="0" marL="0">
               <a:lnSpc>
-                <a:spcPts val="5280"/>
+                <a:spcPts val="7590"/>
               </a:lnSpc>
               <a:buNone/>
             </a:pPr>
             <a:r>
-              <a:rPr lang="en-US" sz="4800" dirty="0" spc="-18" kern="0">
+              <a:rPr lang="en-US" sz="6900" dirty="0" spc="-15" kern="0">
                 <a:solidFill>
                   <a:srgbClr val="F3EEE3"/>
                 </a:solidFill>
@@ -5655,10 +5655,10 @@
                 <a:ea typeface="Bricolage Grotesque ExtraBold" pitchFamily="34" charset="-122"/>
                 <a:cs typeface="Bricolage Grotesque ExtraBold" pitchFamily="34" charset="-120"/>
               </a:rPr>
-              <a:t>docker</a:t>
-            </a:r>
-            <a:r>
-              <a:rPr lang="en-US" sz="4800" dirty="0" spc="0" kern="0">
+              <a:t>Exited</a:t>
+            </a:r>
+            <a:r>
+              <a:rPr lang="en-US" sz="6900" dirty="0" spc="0" kern="0">
                 <a:solidFill>
                   <a:srgbClr val="F3EEE3"/>
                 </a:solidFill>
@@ -5666,10 +5666,10 @@
                 <a:ea typeface="Bricolage Grotesque ExtraBold" pitchFamily="34" charset="-122"/>
                 <a:cs typeface="Bricolage Grotesque ExtraBold" pitchFamily="34" charset="-120"/>
               </a:rPr>
-              <a:t> ps</a:t>
-            </a:r>
-            <a:r>
-              <a:rPr lang="en-US" sz="4800" dirty="0" spc="-1" kern="0">
+              <a:t> hay</a:t>
+            </a:r>
+            <a:r>
+              <a:rPr lang="en-US" sz="6900" dirty="0" spc="-10" kern="0">
                 <a:solidFill>
                   <a:srgbClr val="F3EEE3"/>
                 </a:solidFill>
@@ -5677,42 +5677,9 @@
                 <a:ea typeface="Bricolage Grotesque ExtraBold" pitchFamily="34" charset="-122"/>
                 <a:cs typeface="Bricolage Grotesque ExtraBold" pitchFamily="34" charset="-120"/>
               </a:rPr>
-              <a:t> -a: mọi</a:t>
-            </a:r>
-            <a:r>
-              <a:rPr lang="en-US" sz="4800" dirty="0" spc="-44" kern="0">
-                <a:solidFill>
-                  <a:srgbClr val="F3EEE3"/>
-                </a:solidFill>
-                <a:latin typeface="Bricolage Grotesque ExtraBold" pitchFamily="34" charset="0"/>
-                <a:ea typeface="Bricolage Grotesque ExtraBold" pitchFamily="34" charset="-122"/>
-                <a:cs typeface="Bricolage Grotesque ExtraBold" pitchFamily="34" charset="-120"/>
-              </a:rPr>
-              <a:t> container,</a:t>
-            </a:r>
-            <a:r>
-              <a:rPr lang="en-US" sz="4800" dirty="0" spc="1" kern="0">
-                <a:solidFill>
-                  <a:srgbClr val="F3EEE3"/>
-                </a:solidFill>
-                <a:latin typeface="Bricolage Grotesque ExtraBold" pitchFamily="34" charset="0"/>
-                <a:ea typeface="Bricolage Grotesque ExtraBold" pitchFamily="34" charset="-122"/>
-                <a:cs typeface="Bricolage Grotesque ExtraBold" pitchFamily="34" charset="-120"/>
-              </a:rPr>
-              <a:t> cả</a:t>
-            </a:r>
-            <a:r>
-              <a:rPr lang="en-US" sz="4800" dirty="0" spc="7" kern="0">
-                <a:solidFill>
-                  <a:srgbClr val="F3EEE3"/>
-                </a:solidFill>
-                <a:latin typeface="Bricolage Grotesque ExtraBold" pitchFamily="34" charset="0"/>
-                <a:ea typeface="Bricolage Grotesque ExtraBold" pitchFamily="34" charset="-122"/>
-                <a:cs typeface="Bricolage Grotesque ExtraBold" pitchFamily="34" charset="-120"/>
-              </a:rPr>
-              <a:t> đã dừng</a:t>
-            </a:r>
-            <a:endParaRPr lang="en-US" sz="4800" dirty="0"/>
+              <a:t> Restarting?</a:t>
+            </a:r>
+            <a:endParaRPr lang="en-US" sz="6900" dirty="0"/>
           </a:p>
         </p:txBody>
       </p:sp>
@@ -6894,8 +6861,8 @@
         </p:nvSpPr>
         <p:spPr>
           <a:xfrm>
-            <a:off x="914400" y="1428750"/>
-            <a:ext cx="16192500" cy="1143000"/>
+            <a:off x="914400" y="1219200"/>
+            <a:ext cx="16459200" cy="1047750"/>
           </a:xfrm>
           <a:prstGeom prst="rect">
             <a:avLst/>
@@ -6904,17 +6871,17 @@
           <a:ln/>
         </p:spPr>
         <p:txBody>
-          <a:bodyPr wrap="square" lIns="0" tIns="30480" rIns="0" bIns="-30480" rtlCol="0" anchor="t"/>
+          <a:bodyPr wrap="square" lIns="0" tIns="43815" rIns="0" bIns="-43815" rtlCol="0" anchor="t"/>
           <a:lstStyle/>
           <a:p>
             <a:pPr algn="l" indent="0" marL="0">
               <a:lnSpc>
-                <a:spcPts val="5280"/>
+                <a:spcPts val="7590"/>
               </a:lnSpc>
               <a:buNone/>
             </a:pPr>
             <a:r>
-              <a:rPr lang="en-US" sz="4800" dirty="0" spc="0" kern="0">
+              <a:rPr lang="en-US" sz="6900" dirty="0" spc="-2" kern="0">
                 <a:solidFill>
                   <a:srgbClr val="14161C"/>
                 </a:solidFill>
@@ -6922,10 +6889,10 @@
                 <a:ea typeface="Bricolage Grotesque ExtraBold" pitchFamily="34" charset="-122"/>
                 <a:cs typeface="Bricolage Grotesque ExtraBold" pitchFamily="34" charset="-120"/>
               </a:rPr>
-              <a:t>Có</a:t>
-            </a:r>
-            <a:r>
-              <a:rPr lang="en-US" sz="4800" dirty="0" spc="-1" kern="0">
+              <a:t>Đọc</a:t>
+            </a:r>
+            <a:r>
+              <a:rPr lang="en-US" sz="6900" dirty="0" spc="-57" kern="0">
                 <a:solidFill>
                   <a:srgbClr val="14161C"/>
                 </a:solidFill>
@@ -6933,10 +6900,10 @@
                 <a:ea typeface="Bricolage Grotesque ExtraBold" pitchFamily="34" charset="-122"/>
                 <a:cs typeface="Bricolage Grotesque ExtraBold" pitchFamily="34" charset="-120"/>
               </a:rPr>
-              <a:t> mã</a:t>
-            </a:r>
-            <a:r>
-              <a:rPr lang="en-US" sz="4800" dirty="0" spc="-5" kern="0">
+              <a:t> vài</a:t>
+            </a:r>
+            <a:r>
+              <a:rPr lang="en-US" sz="6900" dirty="0" spc="1" kern="0">
                 <a:solidFill>
                   <a:srgbClr val="14161C"/>
                 </a:solidFill>
@@ -6944,10 +6911,10 @@
                 <a:ea typeface="Bricolage Grotesque ExtraBold" pitchFamily="34" charset="-122"/>
                 <a:cs typeface="Bricolage Grotesque ExtraBold" pitchFamily="34" charset="-120"/>
               </a:rPr>
-              <a:t> thoát</a:t>
-            </a:r>
-            <a:r>
-              <a:rPr lang="en-US" sz="4800" dirty="0" spc="-15" kern="0">
+              <a:t> dòng nhật</a:t>
+            </a:r>
+            <a:r>
+              <a:rPr lang="en-US" sz="6900" dirty="0" spc="-3" kern="0">
                 <a:solidFill>
                   <a:srgbClr val="14161C"/>
                 </a:solidFill>
@@ -6955,10 +6922,10 @@
                 <a:ea typeface="Bricolage Grotesque ExtraBold" pitchFamily="34" charset="-122"/>
                 <a:cs typeface="Bricolage Grotesque ExtraBold" pitchFamily="34" charset="-120"/>
               </a:rPr>
-              <a:t> rồi,</a:t>
-            </a:r>
-            <a:r>
-              <a:rPr lang="en-US" sz="4800" dirty="0" spc="9" kern="0">
+              <a:t> ký</a:t>
+            </a:r>
+            <a:r>
+              <a:rPr lang="en-US" sz="6900" dirty="0" spc="0" kern="0">
                 <a:solidFill>
                   <a:srgbClr val="14161C"/>
                 </a:solidFill>
@@ -6966,42 +6933,9 @@
                 <a:ea typeface="Bricolage Grotesque ExtraBold" pitchFamily="34" charset="-122"/>
                 <a:cs typeface="Bricolage Grotesque ExtraBold" pitchFamily="34" charset="-120"/>
               </a:rPr>
-              <a:t> đọc</a:t>
-            </a:r>
-            <a:r>
-              <a:rPr lang="en-US" sz="4800" dirty="0" spc="-42" kern="0">
-                <a:solidFill>
-                  <a:srgbClr val="14161C"/>
-                </a:solidFill>
-                <a:latin typeface="Bricolage Grotesque ExtraBold" pitchFamily="34" charset="0"/>
-                <a:ea typeface="Bricolage Grotesque ExtraBold" pitchFamily="34" charset="-122"/>
-                <a:cs typeface="Bricolage Grotesque ExtraBold" pitchFamily="34" charset="-120"/>
-              </a:rPr>
-              <a:t> vài</a:t>
-            </a:r>
-            <a:r>
-              <a:rPr lang="en-US" sz="4800" dirty="0" spc="-2" kern="0">
-                <a:solidFill>
-                  <a:srgbClr val="14161C"/>
-                </a:solidFill>
-                <a:latin typeface="Bricolage Grotesque ExtraBold" pitchFamily="34" charset="0"/>
-                <a:ea typeface="Bricolage Grotesque ExtraBold" pitchFamily="34" charset="-122"/>
-                <a:cs typeface="Bricolage Grotesque ExtraBold" pitchFamily="34" charset="-120"/>
-              </a:rPr>
-              <a:t> dòng</a:t>
-            </a:r>
-            <a:r>
-              <a:rPr lang="en-US" sz="4800" dirty="0" spc="-1" kern="0">
-                <a:solidFill>
-                  <a:srgbClr val="14161C"/>
-                </a:solidFill>
-                <a:latin typeface="Bricolage Grotesque ExtraBold" pitchFamily="34" charset="0"/>
-                <a:ea typeface="Bricolage Grotesque ExtraBold" pitchFamily="34" charset="-122"/>
-                <a:cs typeface="Bricolage Grotesque ExtraBold" pitchFamily="34" charset="-120"/>
-              </a:rPr>
               <a:t> cuối</a:t>
             </a:r>
-            <a:endParaRPr lang="en-US" sz="4800" dirty="0"/>
+            <a:endParaRPr lang="en-US" sz="6900" dirty="0"/>
           </a:p>
         </p:txBody>
       </p:sp>
@@ -8318,8 +8252,8 @@
         </p:nvSpPr>
         <p:spPr>
           <a:xfrm>
-            <a:off x="914400" y="1428750"/>
-            <a:ext cx="16192500" cy="1143000"/>
+            <a:off x="914400" y="1219200"/>
+            <a:ext cx="16459200" cy="1047750"/>
           </a:xfrm>
           <a:prstGeom prst="rect">
             <a:avLst/>
@@ -8328,17 +8262,17 @@
           <a:ln/>
         </p:spPr>
         <p:txBody>
-          <a:bodyPr wrap="square" lIns="0" tIns="30480" rIns="0" bIns="-30480" rtlCol="0" anchor="t"/>
+          <a:bodyPr wrap="square" lIns="0" tIns="43815" rIns="0" bIns="-43815" rtlCol="0" anchor="t"/>
           <a:lstStyle/>
           <a:p>
             <a:pPr algn="l" indent="0" marL="0">
               <a:lnSpc>
-                <a:spcPts val="5280"/>
+                <a:spcPts val="7590"/>
               </a:lnSpc>
               <a:buNone/>
             </a:pPr>
             <a:r>
-              <a:rPr lang="en-US" sz="4800" dirty="0" spc="-18" kern="0">
+              <a:rPr lang="en-US" sz="6900" dirty="0" spc="-4" kern="0">
                 <a:solidFill>
                   <a:srgbClr val="F3EEE3"/>
                 </a:solidFill>
@@ -8346,10 +8280,10 @@
                 <a:ea typeface="Bricolage Grotesque ExtraBold" pitchFamily="34" charset="-122"/>
                 <a:cs typeface="Bricolage Grotesque ExtraBold" pitchFamily="34" charset="-120"/>
               </a:rPr>
-              <a:t>docker</a:t>
-            </a:r>
-            <a:r>
-              <a:rPr lang="en-US" sz="4800" dirty="0" spc="0" kern="0">
+              <a:t>Ba</a:t>
+            </a:r>
+            <a:r>
+              <a:rPr lang="en-US" sz="6900" dirty="0" spc="-58" kern="0">
                 <a:solidFill>
                   <a:srgbClr val="F3EEE3"/>
                 </a:solidFill>
@@ -8357,10 +8291,10 @@
                 <a:ea typeface="Bricolage Grotesque ExtraBold" pitchFamily="34" charset="-122"/>
                 <a:cs typeface="Bricolage Grotesque ExtraBold" pitchFamily="34" charset="-120"/>
               </a:rPr>
-              <a:t> inspect</a:t>
-            </a:r>
-            <a:r>
-              <a:rPr lang="en-US" sz="4800" dirty="0" spc="9" kern="0">
+              <a:t> trường</a:t>
+            </a:r>
+            <a:r>
+              <a:rPr lang="en-US" sz="6900" dirty="0" spc="0" kern="0">
                 <a:solidFill>
                   <a:srgbClr val="F3EEE3"/>
                 </a:solidFill>
@@ -8368,10 +8302,10 @@
                 <a:ea typeface="Bricolage Grotesque ExtraBold" pitchFamily="34" charset="-122"/>
                 <a:cs typeface="Bricolage Grotesque ExtraBold" pitchFamily="34" charset="-120"/>
               </a:rPr>
-              <a:t> đọc</a:t>
-            </a:r>
-            <a:r>
-              <a:rPr lang="en-US" sz="4800" dirty="0" spc="-5" kern="0">
+              <a:t> của</a:t>
+            </a:r>
+            <a:r>
+              <a:rPr lang="en-US" sz="6900" dirty="0" spc="-22" kern="0">
                 <a:solidFill>
                   <a:srgbClr val="F3EEE3"/>
                 </a:solidFill>
@@ -8379,42 +8313,9 @@
                 <a:ea typeface="Bricolage Grotesque ExtraBold" pitchFamily="34" charset="-122"/>
                 <a:cs typeface="Bricolage Grotesque ExtraBold" pitchFamily="34" charset="-120"/>
               </a:rPr>
-              <a:t> ba</a:t>
-            </a:r>
-            <a:r>
-              <a:rPr lang="en-US" sz="4800" dirty="0" spc="-40" kern="0">
-                <a:solidFill>
-                  <a:srgbClr val="F3EEE3"/>
-                </a:solidFill>
-                <a:latin typeface="Bricolage Grotesque ExtraBold" pitchFamily="34" charset="0"/>
-                <a:ea typeface="Bricolage Grotesque ExtraBold" pitchFamily="34" charset="-122"/>
-                <a:cs typeface="Bricolage Grotesque ExtraBold" pitchFamily="34" charset="-120"/>
-              </a:rPr>
-              <a:t> trường</a:t>
-            </a:r>
-            <a:r>
-              <a:rPr lang="en-US" sz="4800" dirty="0" spc="-2" kern="0">
-                <a:solidFill>
-                  <a:srgbClr val="F3EEE3"/>
-                </a:solidFill>
-                <a:latin typeface="Bricolage Grotesque ExtraBold" pitchFamily="34" charset="0"/>
-                <a:ea typeface="Bricolage Grotesque ExtraBold" pitchFamily="34" charset="-122"/>
-                <a:cs typeface="Bricolage Grotesque ExtraBold" pitchFamily="34" charset="-120"/>
-              </a:rPr>
-              <a:t> của</a:t>
-            </a:r>
-            <a:r>
-              <a:rPr lang="en-US" sz="4800" dirty="0" spc="-16" kern="0">
-                <a:solidFill>
-                  <a:srgbClr val="F3EEE3"/>
-                </a:solidFill>
-                <a:latin typeface="Bricolage Grotesque ExtraBold" pitchFamily="34" charset="0"/>
-                <a:ea typeface="Bricolage Grotesque ExtraBold" pitchFamily="34" charset="-122"/>
-                <a:cs typeface="Bricolage Grotesque ExtraBold" pitchFamily="34" charset="-120"/>
-              </a:rPr>
               <a:t> State</a:t>
             </a:r>
-            <a:endParaRPr lang="en-US" sz="4800" dirty="0"/>
+            <a:endParaRPr lang="en-US" sz="6900" dirty="0"/>
           </a:p>
         </p:txBody>
       </p:sp>
@@ -9797,8 +9698,8 @@
         </p:nvSpPr>
         <p:spPr>
           <a:xfrm>
-            <a:off x="914400" y="1428750"/>
-            <a:ext cx="16192500" cy="1143000"/>
+            <a:off x="914400" y="1219200"/>
+            <a:ext cx="16459200" cy="1047750"/>
           </a:xfrm>
           <a:prstGeom prst="rect">
             <a:avLst/>
@@ -9807,17 +9708,17 @@
           <a:ln/>
         </p:spPr>
         <p:txBody>
-          <a:bodyPr wrap="square" lIns="0" tIns="30480" rIns="0" bIns="-30480" rtlCol="0" anchor="t"/>
+          <a:bodyPr wrap="square" lIns="0" tIns="43815" rIns="0" bIns="-43815" rtlCol="0" anchor="t"/>
           <a:lstStyle/>
           <a:p>
             <a:pPr algn="l" indent="0" marL="0">
               <a:lnSpc>
-                <a:spcPts val="5280"/>
+                <a:spcPts val="7590"/>
               </a:lnSpc>
               <a:buNone/>
             </a:pPr>
             <a:r>
-              <a:rPr lang="en-US" sz="4800" dirty="0" spc="-6" kern="0">
+              <a:rPr lang="en-US" sz="6900" dirty="0" spc="-1" kern="0">
                 <a:solidFill>
                   <a:srgbClr val="14161C"/>
                 </a:solidFill>
@@ -9825,10 +9726,10 @@
                 <a:ea typeface="Bricolage Grotesque ExtraBold" pitchFamily="34" charset="-122"/>
                 <a:cs typeface="Bricolage Grotesque ExtraBold" pitchFamily="34" charset="-120"/>
               </a:rPr>
-              <a:t>--restart</a:t>
-            </a:r>
-            <a:r>
-              <a:rPr lang="en-US" sz="4800" dirty="0" spc="2" kern="0">
+              <a:t>--restart:</a:t>
+            </a:r>
+            <a:r>
+              <a:rPr lang="en-US" sz="6900" dirty="0" spc="0" kern="0">
                 <a:solidFill>
                   <a:srgbClr val="14161C"/>
                 </a:solidFill>
@@ -9836,53 +9737,9 @@
                 <a:ea typeface="Bricolage Grotesque ExtraBold" pitchFamily="34" charset="-122"/>
                 <a:cs typeface="Bricolage Grotesque ExtraBold" pitchFamily="34" charset="-120"/>
               </a:rPr>
-              <a:t> quyết</a:t>
-            </a:r>
-            <a:r>
-              <a:rPr lang="en-US" sz="4800" dirty="0" spc="14" kern="0">
-                <a:solidFill>
-                  <a:srgbClr val="14161C"/>
-                </a:solidFill>
-                <a:latin typeface="Bricolage Grotesque ExtraBold" pitchFamily="34" charset="0"/>
-                <a:ea typeface="Bricolage Grotesque ExtraBold" pitchFamily="34" charset="-122"/>
-                <a:cs typeface="Bricolage Grotesque ExtraBold" pitchFamily="34" charset="-120"/>
-              </a:rPr>
-              <a:t> định</a:t>
-            </a:r>
-            <a:r>
-              <a:rPr lang="en-US" sz="4800" dirty="0" spc="-2" kern="0">
-                <a:solidFill>
-                  <a:srgbClr val="14161C"/>
-                </a:solidFill>
-                <a:latin typeface="Bricolage Grotesque ExtraBold" pitchFamily="34" charset="0"/>
-                <a:ea typeface="Bricolage Grotesque ExtraBold" pitchFamily="34" charset="-122"/>
-                <a:cs typeface="Bricolage Grotesque ExtraBold" pitchFamily="34" charset="-120"/>
-              </a:rPr>
-              <a:t> container</a:t>
-            </a:r>
-            <a:r>
-              <a:rPr lang="en-US" sz="4800" dirty="0" spc="-1" kern="0">
-                <a:solidFill>
-                  <a:srgbClr val="14161C"/>
-                </a:solidFill>
-                <a:latin typeface="Bricolage Grotesque ExtraBold" pitchFamily="34" charset="0"/>
-                <a:ea typeface="Bricolage Grotesque ExtraBold" pitchFamily="34" charset="-122"/>
-                <a:cs typeface="Bricolage Grotesque ExtraBold" pitchFamily="34" charset="-120"/>
-              </a:rPr>
-              <a:t> có chạy</a:t>
-            </a:r>
-            <a:r>
-              <a:rPr lang="en-US" sz="4800" dirty="0" spc="-2" kern="0">
-                <a:solidFill>
-                  <a:srgbClr val="14161C"/>
-                </a:solidFill>
-                <a:latin typeface="Bricolage Grotesque ExtraBold" pitchFamily="34" charset="0"/>
-                <a:ea typeface="Bricolage Grotesque ExtraBold" pitchFamily="34" charset="-122"/>
-                <a:cs typeface="Bricolage Grotesque ExtraBold" pitchFamily="34" charset="-120"/>
-              </a:rPr>
-              <a:t> lại</a:t>
-            </a:r>
-            <a:endParaRPr lang="en-US" sz="4800" dirty="0"/>
+              <a:t> chạy lại hay không</a:t>
+            </a:r>
+            <a:endParaRPr lang="en-US" sz="6900" dirty="0"/>
           </a:p>
         </p:txBody>
       </p:sp>
@@ -11103,8 +10960,8 @@
         </p:nvSpPr>
         <p:spPr>
           <a:xfrm>
-            <a:off x="914400" y="1428750"/>
-            <a:ext cx="16192500" cy="1143000"/>
+            <a:off x="914400" y="1219200"/>
+            <a:ext cx="16459200" cy="1047750"/>
           </a:xfrm>
           <a:prstGeom prst="rect">
             <a:avLst/>
@@ -11113,17 +10970,17 @@
           <a:ln/>
         </p:spPr>
         <p:txBody>
-          <a:bodyPr wrap="square" lIns="0" tIns="30480" rIns="0" bIns="-30480" rtlCol="0" anchor="t"/>
+          <a:bodyPr wrap="square" lIns="0" tIns="43815" rIns="0" bIns="-43815" rtlCol="0" anchor="t"/>
           <a:lstStyle/>
           <a:p>
             <a:pPr algn="l" indent="0" marL="0">
               <a:lnSpc>
-                <a:spcPts val="5280"/>
+                <a:spcPts val="7590"/>
               </a:lnSpc>
               <a:buNone/>
             </a:pPr>
             <a:r>
-              <a:rPr lang="en-US" sz="4800" dirty="0" spc="-36" kern="0">
+              <a:rPr lang="en-US" sz="6900" dirty="0" spc="8" kern="0">
                 <a:solidFill>
                   <a:srgbClr val="F3EEE3"/>
                 </a:solidFill>
@@ -11131,10 +10988,10 @@
                 <a:ea typeface="Bricolage Grotesque ExtraBold" pitchFamily="34" charset="-122"/>
                 <a:cs typeface="Bricolage Grotesque ExtraBold" pitchFamily="34" charset="-120"/>
               </a:rPr>
-              <a:t>Trạng</a:t>
-            </a:r>
-            <a:r>
-              <a:rPr lang="en-US" sz="4800" dirty="0" spc="-1" kern="0">
+              <a:t>Chỉ</a:t>
+            </a:r>
+            <a:r>
+              <a:rPr lang="en-US" sz="6900" dirty="0" spc="-1" kern="0">
                 <a:solidFill>
                   <a:srgbClr val="F3EEE3"/>
                 </a:solidFill>
@@ -11142,10 +10999,10 @@
                 <a:ea typeface="Bricolage Grotesque ExtraBold" pitchFamily="34" charset="-122"/>
                 <a:cs typeface="Bricolage Grotesque ExtraBold" pitchFamily="34" charset="-120"/>
               </a:rPr>
-              <a:t> thái</a:t>
-            </a:r>
-            <a:r>
-              <a:rPr lang="en-US" sz="4800" dirty="0" spc="-5" kern="0">
+              <a:t> còn</a:t>
+            </a:r>
+            <a:r>
+              <a:rPr lang="en-US" sz="6900" dirty="0" spc="0" kern="0">
                 <a:solidFill>
                   <a:srgbClr val="F3EEE3"/>
                 </a:solidFill>
@@ -11153,10 +11010,10 @@
                 <a:ea typeface="Bricolage Grotesque ExtraBold" pitchFamily="34" charset="-122"/>
                 <a:cs typeface="Bricolage Grotesque ExtraBold" pitchFamily="34" charset="-120"/>
               </a:rPr>
-              <a:t> thoát</a:t>
-            </a:r>
-            <a:r>
-              <a:rPr lang="en-US" sz="4800" dirty="0" spc="-1" kern="0">
+              <a:t> khi</a:t>
+            </a:r>
+            <a:r>
+              <a:rPr lang="en-US" sz="6900" dirty="0" spc="-47" kern="0">
                 <a:solidFill>
                   <a:srgbClr val="F3EEE3"/>
                 </a:solidFill>
@@ -11164,10 +11021,10 @@
                 <a:ea typeface="Bricolage Grotesque ExtraBold" pitchFamily="34" charset="-122"/>
                 <a:cs typeface="Bricolage Grotesque ExtraBold" pitchFamily="34" charset="-120"/>
               </a:rPr>
-              <a:t> chỉ còn</a:t>
-            </a:r>
-            <a:r>
-              <a:rPr lang="en-US" sz="4800" dirty="0" spc="-2" kern="0">
+              <a:t> chưa</a:t>
+            </a:r>
+            <a:r>
+              <a:rPr lang="en-US" sz="6900" dirty="0" spc="-97" kern="0">
                 <a:solidFill>
                   <a:srgbClr val="F3EEE3"/>
                 </a:solidFill>
@@ -11175,31 +11032,9 @@
                 <a:ea typeface="Bricolage Grotesque ExtraBold" pitchFamily="34" charset="-122"/>
                 <a:cs typeface="Bricolage Grotesque ExtraBold" pitchFamily="34" charset="-120"/>
               </a:rPr>
-              <a:t> khi</a:t>
-            </a:r>
-            <a:r>
-              <a:rPr lang="en-US" sz="4800" dirty="0" spc="-33" kern="0">
-                <a:solidFill>
-                  <a:srgbClr val="F3EEE3"/>
-                </a:solidFill>
-                <a:latin typeface="Bricolage Grotesque ExtraBold" pitchFamily="34" charset="0"/>
-                <a:ea typeface="Bricolage Grotesque ExtraBold" pitchFamily="34" charset="-122"/>
-                <a:cs typeface="Bricolage Grotesque ExtraBold" pitchFamily="34" charset="-120"/>
-              </a:rPr>
-              <a:t> chưa</a:t>
-            </a:r>
-            <a:r>
-              <a:rPr lang="en-US" sz="4800" dirty="0" spc="-70" kern="0">
-                <a:solidFill>
-                  <a:srgbClr val="F3EEE3"/>
-                </a:solidFill>
-                <a:latin typeface="Bricolage Grotesque ExtraBold" pitchFamily="34" charset="0"/>
-                <a:ea typeface="Bricolage Grotesque ExtraBold" pitchFamily="34" charset="-122"/>
-                <a:cs typeface="Bricolage Grotesque ExtraBold" pitchFamily="34" charset="-120"/>
-              </a:rPr>
               <a:t> xóa</a:t>
             </a:r>
-            <a:endParaRPr lang="en-US" sz="4800" dirty="0"/>
+            <a:endParaRPr lang="en-US" sz="6900" dirty="0"/>
           </a:p>
         </p:txBody>
       </p:sp>
@@ -13927,8 +13762,8 @@
         </p:nvSpPr>
         <p:spPr>
           <a:xfrm>
-            <a:off x="914400" y="1428750"/>
-            <a:ext cx="16192500" cy="952500"/>
+            <a:off x="914400" y="1219200"/>
+            <a:ext cx="16459200" cy="1047750"/>
           </a:xfrm>
           <a:prstGeom prst="rect">
             <a:avLst/>
@@ -13937,17 +13772,17 @@
           <a:ln/>
         </p:spPr>
         <p:txBody>
-          <a:bodyPr wrap="square" lIns="0" tIns="30480" rIns="0" bIns="-30480" rtlCol="0" anchor="t"/>
+          <a:bodyPr wrap="square" lIns="0" tIns="43815" rIns="0" bIns="-43815" rtlCol="0" anchor="t"/>
           <a:lstStyle/>
           <a:p>
             <a:pPr algn="l" indent="0" marL="0">
               <a:lnSpc>
-                <a:spcPts val="5280"/>
+                <a:spcPts val="7590"/>
               </a:lnSpc>
               <a:buNone/>
             </a:pPr>
             <a:r>
-              <a:rPr lang="en-US" sz="4800" dirty="0" spc="0" kern="0">
+              <a:rPr lang="en-US" sz="6900" dirty="0" spc="-1" kern="0">
                 <a:solidFill>
                   <a:srgbClr val="14161C"/>
                 </a:solidFill>
@@ -13958,7 +13793,7 @@
               <a:t>Bốn</a:t>
             </a:r>
             <a:r>
-              <a:rPr lang="en-US" sz="4800" dirty="0" spc="-1" kern="0">
+              <a:rPr lang="en-US" sz="6900" dirty="0" spc="0" kern="0">
                 <a:solidFill>
                   <a:srgbClr val="14161C"/>
                 </a:solidFill>
@@ -13969,7 +13804,7 @@
               <a:t> chi</a:t>
             </a:r>
             <a:r>
-              <a:rPr lang="en-US" sz="4800" dirty="0" spc="1" kern="0">
+              <a:rPr lang="en-US" sz="6900" dirty="0" spc="2" kern="0">
                 <a:solidFill>
                   <a:srgbClr val="14161C"/>
                 </a:solidFill>
@@ -13980,7 +13815,7 @@
               <a:t> tiết</a:t>
             </a:r>
             <a:r>
-              <a:rPr lang="en-US" sz="4800" dirty="0" spc="4" kern="0">
+              <a:rPr lang="en-US" sz="6900" dirty="0" spc="8" kern="0">
                 <a:solidFill>
                   <a:srgbClr val="14161C"/>
                 </a:solidFill>
@@ -13991,7 +13826,7 @@
               <a:t> đáng</a:t>
             </a:r>
             <a:r>
-              <a:rPr lang="en-US" sz="4800" dirty="0" spc="-2" kern="0">
+              <a:rPr lang="en-US" sz="6900" dirty="0" spc="1" kern="0">
                 <a:solidFill>
                   <a:srgbClr val="14161C"/>
                 </a:solidFill>
@@ -14001,7 +13836,7 @@
               </a:rPr>
               <a:t> nhớ</a:t>
             </a:r>
-            <a:endParaRPr lang="en-US" sz="4800" dirty="0"/>
+            <a:endParaRPr lang="en-US" sz="6900" dirty="0"/>
           </a:p>
         </p:txBody>
       </p:sp>

</xml_diff>

<commit_message>
Slides: sd-13-026, sd-13-027 body text at 34 px
Co-Authored-By: Claude Opus 5.5 <noreply@anthropic.com>
Claude-Session: https://claude.ai/code/session_01TQmrJYLm4GPgtXpQaEk7ey
</commit_message>
<xml_diff>
--- a/system-design-101/vi/lessons/sd-13-026/slides/sd-13-026.pptx
+++ b/system-design-101/vi/lessons/sd-13-026/slides/sd-13-026.pptx
@@ -5735,7 +5735,7 @@
               <a:buNone/>
             </a:pPr>
             <a:r>
-              <a:rPr lang="en-US" sz="2250" b="1" dirty="0" spc="3" kern="0">
+              <a:rPr lang="en-US" sz="2550" b="1" dirty="0" spc="0" kern="0">
                 <a:solidFill>
                   <a:srgbClr val="9AA0B5"/>
                 </a:solidFill>
@@ -5743,9 +5743,20 @@
                 <a:ea typeface="Be Vietnam Pro" pitchFamily="34" charset="-122"/>
                 <a:cs typeface="Be Vietnam Pro" pitchFamily="34" charset="-120"/>
               </a:rPr>
-              <a:t>TRẠNG THÁI</a:t>
-            </a:r>
-            <a:endParaRPr lang="en-US" sz="2250" dirty="0"/>
+              <a:t>TRẠNG</a:t>
+            </a:r>
+            <a:r>
+              <a:rPr lang="en-US" sz="2550" b="1" dirty="0" spc="1" kern="0">
+                <a:solidFill>
+                  <a:srgbClr val="9AA0B5"/>
+                </a:solidFill>
+                <a:latin typeface="Be Vietnam Pro" pitchFamily="34" charset="0"/>
+                <a:ea typeface="Be Vietnam Pro" pitchFamily="34" charset="-122"/>
+                <a:cs typeface="Be Vietnam Pro" pitchFamily="34" charset="-120"/>
+              </a:rPr>
+              <a:t> THÁI</a:t>
+            </a:r>
+            <a:endParaRPr lang="en-US" sz="2550" dirty="0"/>
           </a:p>
         </p:txBody>
       </p:sp>
@@ -5998,7 +6009,7 @@
               <a:buNone/>
             </a:pPr>
             <a:r>
-              <a:rPr lang="en-US" sz="2250" b="1" dirty="0" spc="3" kern="0">
+              <a:rPr lang="en-US" sz="2550" b="1" dirty="0" spc="0" kern="0">
                 <a:solidFill>
                   <a:srgbClr val="9AA0B5"/>
                 </a:solidFill>
@@ -6006,9 +6017,20 @@
                 <a:ea typeface="Be Vietnam Pro" pitchFamily="34" charset="-122"/>
                 <a:cs typeface="Be Vietnam Pro" pitchFamily="34" charset="-120"/>
               </a:rPr>
-              <a:t>TRẠNG THÁI</a:t>
-            </a:r>
-            <a:endParaRPr lang="en-US" sz="2250" dirty="0"/>
+              <a:t>TRẠNG</a:t>
+            </a:r>
+            <a:r>
+              <a:rPr lang="en-US" sz="2550" b="1" dirty="0" spc="1" kern="0">
+                <a:solidFill>
+                  <a:srgbClr val="9AA0B5"/>
+                </a:solidFill>
+                <a:latin typeface="Be Vietnam Pro" pitchFamily="34" charset="0"/>
+                <a:ea typeface="Be Vietnam Pro" pitchFamily="34" charset="-122"/>
+                <a:cs typeface="Be Vietnam Pro" pitchFamily="34" charset="-120"/>
+              </a:rPr>
+              <a:t> THÁI</a:t>
+            </a:r>
+            <a:endParaRPr lang="en-US" sz="2550" dirty="0"/>
           </a:p>
         </p:txBody>
       </p:sp>
@@ -7073,17 +7095,17 @@
           <a:ln/>
         </p:spPr>
         <p:txBody>
-          <a:bodyPr wrap="square" lIns="0" tIns="12954" rIns="0" bIns="-12954" rtlCol="0" anchor="t"/>
+          <a:bodyPr wrap="square" lIns="0" tIns="13764" rIns="0" bIns="-13764" rtlCol="0" anchor="t"/>
           <a:lstStyle/>
           <a:p>
             <a:pPr algn="l" indent="0" marL="0">
               <a:lnSpc>
-                <a:spcPts val="3120"/>
+                <a:spcPts val="3315"/>
               </a:lnSpc>
               <a:buNone/>
             </a:pPr>
             <a:r>
-              <a:rPr lang="en-US" sz="2400" dirty="0" spc="-9" kern="0">
+              <a:rPr lang="en-US" sz="2550" dirty="0" spc="-9" kern="0">
                 <a:solidFill>
                   <a:srgbClr val="14161C"/>
                 </a:solidFill>
@@ -7094,7 +7116,7 @@
               <a:t>Exited</a:t>
             </a:r>
             <a:r>
-              <a:rPr lang="en-US" sz="2400" dirty="0" spc="-27" kern="0">
+              <a:rPr lang="en-US" sz="2550" dirty="0" spc="-27" kern="0">
                 <a:solidFill>
                   <a:srgbClr val="14161C"/>
                 </a:solidFill>
@@ -7105,7 +7127,7 @@
               <a:t> kèm</a:t>
             </a:r>
             <a:r>
-              <a:rPr lang="en-US" sz="2400" dirty="0" spc="4" kern="0">
+              <a:rPr lang="en-US" sz="2550" dirty="0" spc="2" kern="0">
                 <a:solidFill>
                   <a:srgbClr val="14161C"/>
                 </a:solidFill>
@@ -7116,7 +7138,7 @@
               <a:t> mã</a:t>
             </a:r>
             <a:r>
-              <a:rPr lang="en-US" sz="2400" dirty="0" spc="-7" kern="0">
+              <a:rPr lang="en-US" sz="2550" dirty="0" spc="-7" kern="0">
                 <a:solidFill>
                   <a:srgbClr val="14161C"/>
                 </a:solidFill>
@@ -7126,7 +7148,7 @@
               </a:rPr>
               <a:t> thoát.</a:t>
             </a:r>
-            <a:endParaRPr lang="en-US" sz="2400" dirty="0"/>
+            <a:endParaRPr lang="en-US" sz="2550" dirty="0"/>
           </a:p>
         </p:txBody>
       </p:sp>
@@ -7296,7 +7318,7 @@
               <a:buNone/>
             </a:pPr>
             <a:r>
-              <a:rPr lang="en-US" sz="2250" dirty="0" kern="0">
+              <a:rPr lang="en-US" sz="2550" dirty="0" spc="5" kern="0">
                 <a:solidFill>
                   <a:srgbClr val="14161C"/>
                 </a:solidFill>
@@ -7306,7 +7328,7 @@
               </a:rPr>
               <a:t>--tail 50</a:t>
             </a:r>
-            <a:endParaRPr lang="en-US" sz="2250" dirty="0"/>
+            <a:endParaRPr lang="en-US" sz="2550" dirty="0"/>
           </a:p>
         </p:txBody>
       </p:sp>
@@ -7328,17 +7350,17 @@
           <a:ln/>
         </p:spPr>
         <p:txBody>
-          <a:bodyPr wrap="square" lIns="0" tIns="12954" rIns="0" bIns="-12954" rtlCol="0" anchor="t"/>
+          <a:bodyPr wrap="square" lIns="0" tIns="13764" rIns="0" bIns="-13764" rtlCol="0" anchor="t"/>
           <a:lstStyle/>
           <a:p>
             <a:pPr algn="l" indent="0" marL="0">
               <a:lnSpc>
-                <a:spcPts val="3120"/>
+                <a:spcPts val="3315"/>
               </a:lnSpc>
               <a:buNone/>
             </a:pPr>
             <a:r>
-              <a:rPr lang="en-US" sz="2400" dirty="0" spc="-3" kern="0">
+              <a:rPr lang="en-US" sz="2550" dirty="0" spc="-3" kern="0">
                 <a:solidFill>
                   <a:srgbClr val="14161C"/>
                 </a:solidFill>
@@ -7349,7 +7371,7 @@
               <a:t>50</a:t>
             </a:r>
             <a:r>
-              <a:rPr lang="en-US" sz="2400" dirty="0" spc="2" kern="0">
+              <a:rPr lang="en-US" sz="2550" dirty="0" spc="0" kern="0">
                 <a:solidFill>
                   <a:srgbClr val="14161C"/>
                 </a:solidFill>
@@ -7360,7 +7382,7 @@
               <a:t> dòng</a:t>
             </a:r>
             <a:r>
-              <a:rPr lang="en-US" sz="2400" dirty="0" spc="-1" kern="0">
+              <a:rPr lang="en-US" sz="2550" dirty="0" spc="1" kern="0">
                 <a:solidFill>
                   <a:srgbClr val="14161C"/>
                 </a:solidFill>
@@ -7370,7 +7392,7 @@
               </a:rPr>
               <a:t> cuối.</a:t>
             </a:r>
-            <a:endParaRPr lang="en-US" sz="2400" dirty="0"/>
+            <a:endParaRPr lang="en-US" sz="2550" dirty="0"/>
           </a:p>
         </p:txBody>
       </p:sp>
@@ -7555,17 +7577,17 @@
           <a:ln/>
         </p:spPr>
         <p:txBody>
-          <a:bodyPr wrap="square" lIns="0" tIns="12954" rIns="0" bIns="-12954" rtlCol="0" anchor="t"/>
+          <a:bodyPr wrap="square" lIns="0" tIns="13764" rIns="0" bIns="-13764" rtlCol="0" anchor="t"/>
           <a:lstStyle/>
           <a:p>
             <a:pPr algn="l" indent="0" marL="0">
               <a:lnSpc>
-                <a:spcPts val="3120"/>
+                <a:spcPts val="3315"/>
               </a:lnSpc>
               <a:buNone/>
             </a:pPr>
             <a:r>
-              <a:rPr lang="en-US" sz="2400" dirty="0" spc="-29" kern="0">
+              <a:rPr lang="en-US" sz="2550" dirty="0" spc="-33" kern="0">
                 <a:solidFill>
                   <a:srgbClr val="14161C"/>
                 </a:solidFill>
@@ -7576,7 +7598,7 @@
               <a:t>Xem</a:t>
             </a:r>
             <a:r>
-              <a:rPr lang="en-US" sz="2400" dirty="0" spc="-13" kern="0">
+              <a:rPr lang="en-US" sz="2550" dirty="0" spc="-16" kern="0">
                 <a:solidFill>
                   <a:srgbClr val="14161C"/>
                 </a:solidFill>
@@ -7587,7 +7609,7 @@
               <a:t> trạng</a:t>
             </a:r>
             <a:r>
-              <a:rPr lang="en-US" sz="2400" dirty="0" spc="1" kern="0">
+              <a:rPr lang="en-US" sz="2550" dirty="0" spc="1" kern="0">
                 <a:solidFill>
                   <a:srgbClr val="14161C"/>
                 </a:solidFill>
@@ -7598,7 +7620,7 @@
               <a:t> thái</a:t>
             </a:r>
             <a:r>
-              <a:rPr lang="en-US" sz="2400" dirty="0" spc="-2" kern="0">
+              <a:rPr lang="en-US" sz="2550" dirty="0" spc="-1" kern="0">
                 <a:solidFill>
                   <a:srgbClr val="14161C"/>
                 </a:solidFill>
@@ -7609,7 +7631,7 @@
               <a:t> chi</a:t>
             </a:r>
             <a:r>
-              <a:rPr lang="en-US" sz="2400" dirty="0" spc="-4" kern="0">
+              <a:rPr lang="en-US" sz="2550" dirty="0" spc="-2" kern="0">
                 <a:solidFill>
                   <a:srgbClr val="14161C"/>
                 </a:solidFill>
@@ -7619,7 +7641,7 @@
               </a:rPr>
               <a:t> tiết.</a:t>
             </a:r>
-            <a:endParaRPr lang="en-US" sz="2400" dirty="0"/>
+            <a:endParaRPr lang="en-US" sz="2550" dirty="0"/>
           </a:p>
         </p:txBody>
       </p:sp>
@@ -9004,7 +9026,7 @@
               <a:buNone/>
             </a:pPr>
             <a:r>
-              <a:rPr lang="en-US" sz="2400" dirty="0" spc="-20" kern="0">
+              <a:rPr lang="en-US" sz="2550" dirty="0" spc="-22" kern="0">
                 <a:solidFill>
                   <a:srgbClr val="9AA0B5"/>
                 </a:solidFill>
@@ -9015,7 +9037,7 @@
               <a:t>false</a:t>
             </a:r>
             <a:r>
-              <a:rPr lang="en-US" sz="2400" dirty="0" spc="7" kern="0">
+              <a:rPr lang="en-US" sz="2550" dirty="0" spc="7" kern="0">
                 <a:solidFill>
                   <a:srgbClr val="9AA0B5"/>
                 </a:solidFill>
@@ -9026,7 +9048,7 @@
               <a:t> chưa</a:t>
             </a:r>
             <a:r>
-              <a:rPr lang="en-US" sz="2400" dirty="0" spc="0" kern="0">
+              <a:rPr lang="en-US" sz="2550" dirty="0" spc="-3" kern="0">
                 <a:solidFill>
                   <a:srgbClr val="9AA0B5"/>
                 </a:solidFill>
@@ -9037,7 +9059,7 @@
               <a:t> bảo</a:t>
             </a:r>
             <a:r>
-              <a:rPr lang="en-US" sz="2400" dirty="0" spc="15" kern="0">
+              <a:rPr lang="en-US" sz="2550" dirty="0" spc="13" kern="0">
                 <a:solidFill>
                   <a:srgbClr val="9AA0B5"/>
                 </a:solidFill>
@@ -9048,7 +9070,7 @@
               <a:t> đảm</a:t>
             </a:r>
             <a:r>
-              <a:rPr lang="en-US" sz="2400" dirty="0" spc="5" kern="0">
+              <a:rPr lang="en-US" sz="2550" dirty="0" spc="2" kern="0">
                 <a:solidFill>
                   <a:srgbClr val="9AA0B5"/>
                 </a:solidFill>
@@ -9059,7 +9081,7 @@
               <a:t> mã</a:t>
             </a:r>
             <a:r>
-              <a:rPr lang="en-US" sz="2400" dirty="0" spc="-1" kern="0">
+              <a:rPr lang="en-US" sz="2550" dirty="0" spc="-2" kern="0">
                 <a:solidFill>
                   <a:srgbClr val="9AA0B5"/>
                 </a:solidFill>
@@ -9070,7 +9092,7 @@
               <a:t> 137</a:t>
             </a:r>
             <a:r>
-              <a:rPr lang="en-US" sz="2400" dirty="0" spc="1" kern="0">
+              <a:rPr lang="en-US" sz="2550" dirty="0" spc="0" kern="0">
                 <a:solidFill>
                   <a:srgbClr val="9AA0B5"/>
                 </a:solidFill>
@@ -9078,10 +9100,10 @@
                 <a:ea typeface="Be Vietnam Pro" pitchFamily="34" charset="-122"/>
                 <a:cs typeface="Be Vietnam Pro" pitchFamily="34" charset="-120"/>
               </a:rPr>
-              <a:t> không</a:t>
-            </a:r>
-            <a:r>
-              <a:rPr lang="en-US" sz="2400" dirty="0" spc="2" kern="0">
+              <a:t> không do</a:t>
+            </a:r>
+            <a:r>
+              <a:rPr lang="en-US" sz="2550" dirty="0" spc="-5" kern="0">
                 <a:solidFill>
                   <a:srgbClr val="9AA0B5"/>
                 </a:solidFill>
@@ -9089,10 +9111,10 @@
                 <a:ea typeface="Be Vietnam Pro" pitchFamily="34" charset="-122"/>
                 <a:cs typeface="Be Vietnam Pro" pitchFamily="34" charset="-120"/>
               </a:rPr>
-              <a:t> do</a:t>
-            </a:r>
-            <a:r>
-              <a:rPr lang="en-US" sz="2400" dirty="0" spc="-2" kern="0">
+              <a:t> bộ</a:t>
+            </a:r>
+            <a:r>
+              <a:rPr lang="en-US" sz="2550" dirty="0" spc="0" kern="0">
                 <a:solidFill>
                   <a:srgbClr val="9AA0B5"/>
                 </a:solidFill>
@@ -9100,10 +9122,10 @@
                 <a:ea typeface="Be Vietnam Pro" pitchFamily="34" charset="-122"/>
                 <a:cs typeface="Be Vietnam Pro" pitchFamily="34" charset="-120"/>
               </a:rPr>
-              <a:t> bộ</a:t>
-            </a:r>
-            <a:r>
-              <a:rPr lang="en-US" sz="2400" dirty="0" spc="1" kern="0">
+              <a:t> nhớ:</a:t>
+            </a:r>
+            <a:r>
+              <a:rPr lang="en-US" sz="2550" dirty="0" spc="13" kern="0">
                 <a:solidFill>
                   <a:srgbClr val="9AA0B5"/>
                 </a:solidFill>
@@ -9111,10 +9133,10 @@
                 <a:ea typeface="Be Vietnam Pro" pitchFamily="34" charset="-122"/>
                 <a:cs typeface="Be Vietnam Pro" pitchFamily="34" charset="-120"/>
               </a:rPr>
-              <a:t> nhớ:</a:t>
-            </a:r>
-            <a:r>
-              <a:rPr lang="en-US" sz="2400" dirty="0" spc="12" kern="0">
+              <a:t> đối</a:t>
+            </a:r>
+            <a:r>
+              <a:rPr lang="en-US" sz="2550" dirty="0" spc="1" kern="0">
                 <a:solidFill>
                   <a:srgbClr val="9AA0B5"/>
                 </a:solidFill>
@@ -9122,10 +9144,10 @@
                 <a:ea typeface="Be Vietnam Pro" pitchFamily="34" charset="-122"/>
                 <a:cs typeface="Be Vietnam Pro" pitchFamily="34" charset="-120"/>
               </a:rPr>
-              <a:t> đối</a:t>
-            </a:r>
-            <a:r>
-              <a:rPr lang="en-US" sz="2400" dirty="0" spc="-2" kern="0">
+              <a:t> chiếu</a:t>
+            </a:r>
+            <a:r>
+              <a:rPr lang="en-US" sz="2550" dirty="0" spc="-10" kern="0">
                 <a:solidFill>
                   <a:srgbClr val="9AA0B5"/>
                 </a:solidFill>
@@ -9133,10 +9155,10 @@
                 <a:ea typeface="Be Vietnam Pro" pitchFamily="34" charset="-122"/>
                 <a:cs typeface="Be Vietnam Pro" pitchFamily="34" charset="-120"/>
               </a:rPr>
-              <a:t> chiếu</a:t>
-            </a:r>
-            <a:r>
-              <a:rPr lang="en-US" sz="2400" dirty="0" spc="-8" kern="0">
+              <a:t> nhật</a:t>
+            </a:r>
+            <a:r>
+              <a:rPr lang="en-US" sz="2550" dirty="0" spc="1" kern="0">
                 <a:solidFill>
                   <a:srgbClr val="9AA0B5"/>
                 </a:solidFill>
@@ -9144,10 +9166,10 @@
                 <a:ea typeface="Be Vietnam Pro" pitchFamily="34" charset="-122"/>
                 <a:cs typeface="Be Vietnam Pro" pitchFamily="34" charset="-120"/>
               </a:rPr>
-              <a:t> nhật</a:t>
-            </a:r>
-            <a:r>
-              <a:rPr lang="en-US" sz="2400" dirty="0" spc="-1" kern="0">
+              <a:t> ký</a:t>
+            </a:r>
+            <a:r>
+              <a:rPr lang="en-US" sz="2550" dirty="0" spc="-13" kern="0">
                 <a:solidFill>
                   <a:srgbClr val="9AA0B5"/>
                 </a:solidFill>
@@ -9155,20 +9177,9 @@
                 <a:ea typeface="Be Vietnam Pro" pitchFamily="34" charset="-122"/>
                 <a:cs typeface="Be Vietnam Pro" pitchFamily="34" charset="-120"/>
               </a:rPr>
-              <a:t> ký</a:t>
-            </a:r>
-            <a:r>
-              <a:rPr lang="en-US" sz="2400" dirty="0" spc="-14" kern="0">
-                <a:solidFill>
-                  <a:srgbClr val="9AA0B5"/>
-                </a:solidFill>
-                <a:latin typeface="Be Vietnam Pro" pitchFamily="34" charset="0"/>
-                <a:ea typeface="Be Vietnam Pro" pitchFamily="34" charset="-122"/>
-                <a:cs typeface="Be Vietnam Pro" pitchFamily="34" charset="-120"/>
-              </a:rPr>
               <a:t> kernel.</a:t>
             </a:r>
-            <a:endParaRPr lang="en-US" sz="2400" dirty="0"/>
+            <a:endParaRPr lang="en-US" sz="2550" dirty="0"/>
           </a:p>
         </p:txBody>
       </p:sp>
@@ -9817,8 +9828,8 @@
         </p:nvSpPr>
         <p:spPr>
           <a:xfrm>
-            <a:off x="4953000" y="3219450"/>
-            <a:ext cx="6286500" cy="476250"/>
+            <a:off x="5810250" y="3219450"/>
+            <a:ext cx="5429250" cy="476250"/>
           </a:xfrm>
           <a:prstGeom prst="rect">
             <a:avLst/>
@@ -9834,7 +9845,7 @@
               <a:buNone/>
             </a:pPr>
             <a:r>
-              <a:rPr lang="en-US" sz="2400" dirty="0" spc="-1" kern="0">
+              <a:rPr lang="en-US" sz="2550" dirty="0" spc="1" kern="0">
                 <a:solidFill>
                   <a:srgbClr val="6B6A66"/>
                 </a:solidFill>
@@ -9845,7 +9856,7 @@
               <a:t>Mặc</a:t>
             </a:r>
             <a:r>
-              <a:rPr lang="en-US" sz="2400" dirty="0" spc="16" kern="0">
+              <a:rPr lang="en-US" sz="2550" dirty="0" spc="18" kern="0">
                 <a:solidFill>
                   <a:srgbClr val="6B6A66"/>
                 </a:solidFill>
@@ -9855,7 +9866,7 @@
               </a:rPr>
               <a:t> định.</a:t>
             </a:r>
-            <a:endParaRPr lang="en-US" sz="2400" dirty="0"/>
+            <a:endParaRPr lang="en-US" sz="2550" dirty="0"/>
           </a:p>
         </p:txBody>
       </p:sp>
@@ -9894,8 +9905,8 @@
         </p:nvSpPr>
         <p:spPr>
           <a:xfrm>
-            <a:off x="1295400" y="4400550"/>
-            <a:ext cx="3619500" cy="762000"/>
+            <a:off x="1295400" y="4533900"/>
+            <a:ext cx="4286250" cy="476250"/>
           </a:xfrm>
           <a:prstGeom prst="rect">
             <a:avLst/>
@@ -9904,17 +9915,17 @@
           <a:ln/>
         </p:spPr>
         <p:txBody>
-          <a:bodyPr wrap="square" lIns="0" tIns="13557" rIns="0" bIns="-13557" rtlCol="0" anchor="t"/>
+          <a:bodyPr wrap="square" lIns="0" tIns="15367" rIns="0" bIns="-15367" rtlCol="0" anchor="t"/>
           <a:lstStyle/>
           <a:p>
             <a:pPr algn="l" indent="0" marL="0">
               <a:lnSpc>
-                <a:spcPts val="2813"/>
+                <a:spcPts val="3188"/>
               </a:lnSpc>
               <a:buNone/>
             </a:pPr>
             <a:r>
-              <a:rPr lang="en-US" sz="2250" b="1" dirty="0" kern="0">
+              <a:rPr lang="en-US" sz="2550" b="1" dirty="0" spc="5" kern="0">
                 <a:solidFill>
                   <a:srgbClr val="B45309"/>
                 </a:solidFill>
@@ -9924,7 +9935,7 @@
               </a:rPr>
               <a:t>on-failure [:số lần]</a:t>
             </a:r>
-            <a:endParaRPr lang="en-US" sz="2250" dirty="0"/>
+            <a:endParaRPr lang="en-US" sz="2550" dirty="0"/>
           </a:p>
         </p:txBody>
       </p:sp>
@@ -9936,8 +9947,8 @@
         </p:nvSpPr>
         <p:spPr>
           <a:xfrm>
-            <a:off x="4953000" y="4552950"/>
-            <a:ext cx="6286500" cy="476250"/>
+            <a:off x="5810250" y="4552950"/>
+            <a:ext cx="5429250" cy="476250"/>
           </a:xfrm>
           <a:prstGeom prst="rect">
             <a:avLst/>
@@ -9953,7 +9964,7 @@
               <a:buNone/>
             </a:pPr>
             <a:r>
-              <a:rPr lang="en-US" sz="2400" dirty="0" spc="-1" kern="0">
+              <a:rPr lang="en-US" sz="2550" dirty="0" spc="1" kern="0">
                 <a:solidFill>
                   <a:srgbClr val="14161C"/>
                 </a:solidFill>
@@ -9964,7 +9975,7 @@
               <a:t>Chỉ</a:t>
             </a:r>
             <a:r>
-              <a:rPr lang="en-US" sz="2400" dirty="0" spc="-7" kern="0">
+              <a:rPr lang="en-US" sz="2550" dirty="0" spc="-7" kern="0">
                 <a:solidFill>
                   <a:srgbClr val="14161C"/>
                 </a:solidFill>
@@ -9975,7 +9986,7 @@
               <a:t> chạy</a:t>
             </a:r>
             <a:r>
-              <a:rPr lang="en-US" sz="2400" dirty="0" spc="1" kern="0">
+              <a:rPr lang="en-US" sz="2550" dirty="0" spc="0" kern="0">
                 <a:solidFill>
                   <a:srgbClr val="14161C"/>
                 </a:solidFill>
@@ -9986,7 +9997,7 @@
               <a:t> lại</a:t>
             </a:r>
             <a:r>
-              <a:rPr lang="en-US" sz="2400" dirty="0" spc="-2" kern="0">
+              <a:rPr lang="en-US" sz="2550" dirty="0" spc="-1" kern="0">
                 <a:solidFill>
                   <a:srgbClr val="14161C"/>
                 </a:solidFill>
@@ -9997,7 +10008,7 @@
               <a:t> khi</a:t>
             </a:r>
             <a:r>
-              <a:rPr lang="en-US" sz="2400" dirty="0" spc="3" kern="0">
+              <a:rPr lang="en-US" sz="2550" dirty="0" spc="2" kern="0">
                 <a:solidFill>
                   <a:srgbClr val="14161C"/>
                 </a:solidFill>
@@ -10008,7 +10019,7 @@
               <a:t> mã</a:t>
             </a:r>
             <a:r>
-              <a:rPr lang="en-US" sz="2400" dirty="0" spc="-7" kern="0">
+              <a:rPr lang="en-US" sz="2550" dirty="0" spc="-9" kern="0">
                 <a:solidFill>
                   <a:srgbClr val="14161C"/>
                 </a:solidFill>
@@ -10019,7 +10030,7 @@
               <a:t> thoát</a:t>
             </a:r>
             <a:r>
-              <a:rPr lang="en-US" sz="2400" dirty="0" spc="-1" kern="0">
+              <a:rPr lang="en-US" sz="2550" dirty="0" spc="0" kern="0">
                 <a:solidFill>
                   <a:srgbClr val="14161C"/>
                 </a:solidFill>
@@ -10027,9 +10038,20 @@
                 <a:ea typeface="Be Vietnam Pro" pitchFamily="34" charset="-122"/>
                 <a:cs typeface="Be Vietnam Pro" pitchFamily="34" charset="-120"/>
               </a:rPr>
-              <a:t> khác 0.</a:t>
-            </a:r>
-            <a:endParaRPr lang="en-US" sz="2400" dirty="0"/>
+              <a:t> khác</a:t>
+            </a:r>
+            <a:r>
+              <a:rPr lang="en-US" sz="2550" dirty="0" spc="1" kern="0">
+                <a:solidFill>
+                  <a:srgbClr val="14161C"/>
+                </a:solidFill>
+                <a:latin typeface="Be Vietnam Pro" pitchFamily="34" charset="0"/>
+                <a:ea typeface="Be Vietnam Pro" pitchFamily="34" charset="-122"/>
+                <a:cs typeface="Be Vietnam Pro" pitchFamily="34" charset="-120"/>
+              </a:rPr>
+              <a:t> 0.</a:t>
+            </a:r>
+            <a:endParaRPr lang="en-US" sz="2550" dirty="0"/>
           </a:p>
         </p:txBody>
       </p:sp>
@@ -10397,17 +10419,17 @@
           <a:ln/>
         </p:spPr>
         <p:txBody>
-          <a:bodyPr wrap="square" lIns="0" tIns="12954" rIns="0" bIns="-12954" rtlCol="0" anchor="t"/>
+          <a:bodyPr wrap="square" lIns="0" tIns="13764" rIns="0" bIns="-13764" rtlCol="0" anchor="t"/>
           <a:lstStyle/>
           <a:p>
             <a:pPr algn="l" indent="0" marL="0">
               <a:lnSpc>
-                <a:spcPts val="3120"/>
+                <a:spcPts val="3315"/>
               </a:lnSpc>
               <a:buNone/>
             </a:pPr>
             <a:r>
-              <a:rPr lang="en-US" sz="2400" dirty="0" spc="-2" kern="0">
+              <a:rPr lang="en-US" sz="2550" dirty="0" spc="1" kern="0">
                 <a:solidFill>
                   <a:srgbClr val="E4E1D8"/>
                 </a:solidFill>
@@ -10418,7 +10440,7 @@
               <a:t>chỉ</a:t>
             </a:r>
             <a:r>
-              <a:rPr lang="en-US" sz="2400" dirty="0" spc="0" kern="0">
+              <a:rPr lang="en-US" sz="2550" dirty="0" spc="0" kern="0">
                 <a:solidFill>
                   <a:srgbClr val="E4E1D8"/>
                 </a:solidFill>
@@ -10429,7 +10451,7 @@
               <a:t> che</a:t>
             </a:r>
             <a:r>
-              <a:rPr lang="en-US" sz="2400" dirty="0" spc="8" kern="0">
+              <a:rPr lang="en-US" sz="2550" dirty="0" spc="10" kern="0">
                 <a:solidFill>
                   <a:srgbClr val="E4E1D8"/>
                 </a:solidFill>
@@ -10440,7 +10462,7 @@
               <a:t> triệu</a:t>
             </a:r>
             <a:r>
-              <a:rPr lang="en-US" sz="2400" dirty="0" spc="15" kern="0">
+              <a:rPr lang="en-US" sz="2550" dirty="0" spc="15" kern="0">
                 <a:solidFill>
                   <a:srgbClr val="E4E1D8"/>
                 </a:solidFill>
@@ -10450,7 +10472,7 @@
               </a:rPr>
               <a:t> chứng.</a:t>
             </a:r>
-            <a:endParaRPr lang="en-US" sz="2400" dirty="0"/>
+            <a:endParaRPr lang="en-US" sz="2550" dirty="0"/>
           </a:p>
         </p:txBody>
       </p:sp>
@@ -11219,17 +11241,17 @@
           <a:ln/>
         </p:spPr>
         <p:txBody>
-          <a:bodyPr wrap="square" lIns="0" tIns="8557" rIns="0" bIns="-8557" rtlCol="0" anchor="t"/>
+          <a:bodyPr wrap="square" lIns="0" tIns="9700" rIns="0" bIns="-9700" rtlCol="0" anchor="t"/>
           <a:lstStyle/>
           <a:p>
             <a:pPr algn="l" indent="0" marL="0">
               <a:lnSpc>
-                <a:spcPts val="3038"/>
+                <a:spcPts val="3443"/>
               </a:lnSpc>
               <a:buNone/>
             </a:pPr>
             <a:r>
-              <a:rPr lang="en-US" sz="2250" dirty="0" spc="4" kern="0">
+              <a:rPr lang="en-US" sz="2550" dirty="0" spc="3" kern="0">
                 <a:solidFill>
                   <a:srgbClr val="9AA0B5"/>
                 </a:solidFill>
@@ -11240,7 +11262,7 @@
               <a:t>Bỏ</a:t>
             </a:r>
             <a:r>
-              <a:rPr lang="en-US" sz="2250" dirty="0" spc="5" kern="0">
+              <a:rPr lang="en-US" sz="2550" dirty="0" spc="0" kern="0">
                 <a:solidFill>
                   <a:srgbClr val="9AA0B5"/>
                 </a:solidFill>
@@ -11251,7 +11273,7 @@
               <a:t> cờ</a:t>
             </a:r>
             <a:r>
-              <a:rPr lang="en-US" sz="2250" dirty="0" spc="-9" kern="0">
+              <a:rPr lang="en-US" sz="2550" dirty="0" spc="-10" kern="0">
                 <a:solidFill>
                   <a:srgbClr val="9AA0B5"/>
                 </a:solidFill>
@@ -11262,7 +11284,7 @@
               <a:t> này</a:t>
             </a:r>
             <a:r>
-              <a:rPr lang="en-US" sz="2250" dirty="0" spc="0" kern="0">
+              <a:rPr lang="en-US" sz="2550" dirty="0" spc="0" kern="0">
                 <a:solidFill>
                   <a:srgbClr val="9AA0B5"/>
                 </a:solidFill>
@@ -11273,7 +11295,7 @@
               <a:t> khi</a:t>
             </a:r>
             <a:r>
-              <a:rPr lang="en-US" sz="2250" dirty="0" spc="9" kern="0">
+              <a:rPr lang="en-US" sz="2550" dirty="0" spc="10" kern="0">
                 <a:solidFill>
                   <a:srgbClr val="9AA0B5"/>
                 </a:solidFill>
@@ -11284,7 +11306,7 @@
               <a:t> đang</a:t>
             </a:r>
             <a:r>
-              <a:rPr lang="en-US" sz="2250" dirty="0" spc="-1" kern="0">
+              <a:rPr lang="en-US" sz="2550" dirty="0" spc="3" kern="0">
                 <a:solidFill>
                   <a:srgbClr val="9AA0B5"/>
                 </a:solidFill>
@@ -11295,7 +11317,7 @@
               <a:t> tìm</a:t>
             </a:r>
             <a:r>
-              <a:rPr lang="en-US" sz="2250" dirty="0" spc="2" kern="0">
+              <a:rPr lang="en-US" sz="2550" dirty="0" spc="0" kern="0">
                 <a:solidFill>
                   <a:srgbClr val="9AA0B5"/>
                 </a:solidFill>
@@ -11305,7 +11327,7 @@
               </a:rPr>
               <a:t> lỗi.</a:t>
             </a:r>
-            <a:endParaRPr lang="en-US" sz="2250" dirty="0"/>
+            <a:endParaRPr lang="en-US" sz="2550" dirty="0"/>
           </a:p>
         </p:txBody>
       </p:sp>
@@ -11512,17 +11534,17 @@
           <a:ln/>
         </p:spPr>
         <p:txBody>
-          <a:bodyPr wrap="square" lIns="0" tIns="8557" rIns="0" bIns="-8557" rtlCol="0" anchor="t"/>
+          <a:bodyPr wrap="square" lIns="0" tIns="9700" rIns="0" bIns="-9700" rtlCol="0" anchor="t"/>
           <a:lstStyle/>
           <a:p>
             <a:pPr algn="l" indent="0" marL="0">
               <a:lnSpc>
-                <a:spcPts val="3038"/>
+                <a:spcPts val="3443"/>
               </a:lnSpc>
               <a:buNone/>
             </a:pPr>
             <a:r>
-              <a:rPr lang="en-US" sz="2250" dirty="0" spc="1" kern="0">
+              <a:rPr lang="en-US" sz="2550" dirty="0" spc="-1" kern="0">
                 <a:solidFill>
                   <a:srgbClr val="9AA0B5"/>
                 </a:solidFill>
@@ -11533,7 +11555,7 @@
               <a:t>Không</a:t>
             </a:r>
             <a:r>
-              <a:rPr lang="en-US" sz="2250" dirty="0" spc="-1" kern="0">
+              <a:rPr lang="en-US" sz="2550" dirty="0" spc="-3" kern="0">
                 <a:solidFill>
                   <a:srgbClr val="9AA0B5"/>
                 </a:solidFill>
@@ -11544,7 +11566,7 @@
               <a:t> bàn</a:t>
             </a:r>
             <a:r>
-              <a:rPr lang="en-US" sz="2250" dirty="0" spc="0" kern="0">
+              <a:rPr lang="en-US" sz="2550" dirty="0" spc="-1" kern="0">
                 <a:solidFill>
                   <a:srgbClr val="9AA0B5"/>
                 </a:solidFill>
@@ -11555,7 +11577,7 @@
               <a:t> lỗi</a:t>
             </a:r>
             <a:r>
-              <a:rPr lang="en-US" sz="2250" dirty="0" spc="-30" kern="0">
+              <a:rPr lang="en-US" sz="2550" dirty="0" spc="-31" kern="0">
                 <a:solidFill>
                   <a:srgbClr val="9AA0B5"/>
                 </a:solidFill>
@@ -11566,7 +11588,7 @@
               <a:t> kéo</a:t>
             </a:r>
             <a:r>
-              <a:rPr lang="en-US" sz="2250" dirty="0" spc="-9" kern="0">
+              <a:rPr lang="en-US" sz="2550" dirty="0" spc="-7" kern="0">
                 <a:solidFill>
                   <a:srgbClr val="9AA0B5"/>
                 </a:solidFill>
@@ -11577,7 +11599,7 @@
               <a:t> image,</a:t>
             </a:r>
             <a:r>
-              <a:rPr lang="en-US" sz="2250" dirty="0" spc="-1" kern="0">
+              <a:rPr lang="en-US" sz="2550" dirty="0" spc="1" kern="0">
                 <a:solidFill>
                   <a:srgbClr val="9AA0B5"/>
                 </a:solidFill>
@@ -11588,7 +11610,7 @@
               <a:t> mạng</a:t>
             </a:r>
             <a:r>
-              <a:rPr lang="en-US" sz="2250" dirty="0" spc="-9" kern="0">
+              <a:rPr lang="en-US" sz="2550" dirty="0" spc="-10" kern="0">
                 <a:solidFill>
                   <a:srgbClr val="9AA0B5"/>
                 </a:solidFill>
@@ -11599,7 +11621,7 @@
               <a:t> hay</a:t>
             </a:r>
             <a:r>
-              <a:rPr lang="en-US" sz="2250" dirty="0" spc="1" kern="0">
+              <a:rPr lang="en-US" sz="2550" dirty="0" spc="1" kern="0">
                 <a:solidFill>
                   <a:srgbClr val="9AA0B5"/>
                 </a:solidFill>
@@ -11609,7 +11631,7 @@
               </a:rPr>
               <a:t> build.</a:t>
             </a:r>
-            <a:endParaRPr lang="en-US" sz="2250" dirty="0"/>
+            <a:endParaRPr lang="en-US" sz="2550" dirty="0"/>
           </a:p>
         </p:txBody>
       </p:sp>
@@ -11827,17 +11849,17 @@
           <a:ln/>
         </p:spPr>
         <p:txBody>
-          <a:bodyPr wrap="square" lIns="0" tIns="8557" rIns="0" bIns="-8557" rtlCol="0" anchor="t"/>
+          <a:bodyPr wrap="square" lIns="0" tIns="9700" rIns="0" bIns="-9700" rtlCol="0" anchor="t"/>
           <a:lstStyle/>
           <a:p>
             <a:pPr algn="l" indent="0" marL="0">
               <a:lnSpc>
-                <a:spcPts val="3038"/>
+                <a:spcPts val="3443"/>
               </a:lnSpc>
               <a:buNone/>
             </a:pPr>
             <a:r>
-              <a:rPr lang="en-US" sz="2250" dirty="0" spc="-1" kern="0">
+              <a:rPr lang="en-US" sz="2550" dirty="0" spc="-1" kern="0">
                 <a:solidFill>
                   <a:srgbClr val="9AA0B5"/>
                 </a:solidFill>
@@ -11848,7 +11870,7 @@
               <a:t>Cùng</a:t>
             </a:r>
             <a:r>
-              <a:rPr lang="en-US" sz="2250" dirty="0" spc="-2" kern="0">
+              <a:rPr lang="en-US" sz="2550" dirty="0" spc="1" kern="0">
                 <a:solidFill>
                   <a:srgbClr val="9AA0B5"/>
                 </a:solidFill>
@@ -11859,7 +11881,7 @@
               <a:t> mã,</a:t>
             </a:r>
             <a:r>
-              <a:rPr lang="en-US" sz="2250" dirty="0" spc="0" kern="0">
+              <a:rPr lang="en-US" sz="2550" dirty="0" spc="0" kern="0">
                 <a:solidFill>
                   <a:srgbClr val="9AA0B5"/>
                 </a:solidFill>
@@ -11870,7 +11892,7 @@
               <a:t> khác</a:t>
             </a:r>
             <a:r>
-              <a:rPr lang="en-US" sz="2250" dirty="0" spc="-1" kern="0">
+              <a:rPr lang="en-US" sz="2550" dirty="0" spc="1" kern="0">
                 <a:solidFill>
                   <a:srgbClr val="9AA0B5"/>
                 </a:solidFill>
@@ -11881,7 +11903,7 @@
               <a:t> nghĩa</a:t>
             </a:r>
             <a:r>
-              <a:rPr lang="en-US" sz="2250" dirty="0" spc="6" kern="0">
+              <a:rPr lang="en-US" sz="2550" dirty="0" spc="6" kern="0">
                 <a:solidFill>
                   <a:srgbClr val="9AA0B5"/>
                 </a:solidFill>
@@ -11892,7 +11914,7 @@
               <a:t> giữa</a:t>
             </a:r>
             <a:r>
-              <a:rPr lang="en-US" sz="2250" dirty="0" spc="2" kern="0">
+              <a:rPr lang="en-US" sz="2550" dirty="0" spc="1" kern="0">
                 <a:solidFill>
                   <a:srgbClr val="9AA0B5"/>
                 </a:solidFill>
@@ -11903,7 +11925,7 @@
               <a:t> các</a:t>
             </a:r>
             <a:r>
-              <a:rPr lang="en-US" sz="2250" dirty="0" spc="24" kern="0">
+              <a:rPr lang="en-US" sz="2550" dirty="0" spc="24" kern="0">
                 <a:solidFill>
                   <a:srgbClr val="9AA0B5"/>
                 </a:solidFill>
@@ -11914,7 +11936,7 @@
               <a:t> ứng</a:t>
             </a:r>
             <a:r>
-              <a:rPr lang="en-US" sz="2250" dirty="0" spc="3" kern="0">
+              <a:rPr lang="en-US" sz="2550" dirty="0" spc="0" kern="0">
                 <a:solidFill>
                   <a:srgbClr val="9AA0B5"/>
                 </a:solidFill>
@@ -11924,7 +11946,7 @@
               </a:rPr>
               <a:t> dụng.</a:t>
             </a:r>
-            <a:endParaRPr lang="en-US" sz="2250" dirty="0"/>
+            <a:endParaRPr lang="en-US" sz="2550" dirty="0"/>
           </a:p>
         </p:txBody>
       </p:sp>
@@ -12629,17 +12651,17 @@
           <a:ln/>
         </p:spPr>
         <p:txBody>
-          <a:bodyPr wrap="square" lIns="0" tIns="9144" rIns="0" bIns="-9144" rtlCol="0" anchor="t"/>
+          <a:bodyPr wrap="square" lIns="0" tIns="9700" rIns="0" bIns="-9700" rtlCol="0" anchor="t"/>
           <a:lstStyle/>
           <a:p>
             <a:pPr algn="l" indent="0" marL="0">
               <a:lnSpc>
-                <a:spcPts val="3240"/>
+                <a:spcPts val="3443"/>
               </a:lnSpc>
               <a:buNone/>
             </a:pPr>
             <a:r>
-              <a:rPr lang="en-US" sz="2400" dirty="0" spc="6" kern="0">
+              <a:rPr lang="en-US" sz="2550" dirty="0" spc="5" kern="0">
                 <a:solidFill>
                   <a:srgbClr val="14161C"/>
                 </a:solidFill>
@@ -12650,7 +12672,7 @@
               <a:t>Thường</a:t>
             </a:r>
             <a:r>
-              <a:rPr lang="en-US" sz="2400" dirty="0" spc="2" kern="0">
+              <a:rPr lang="en-US" sz="2550" dirty="0" spc="0" kern="0">
                 <a:solidFill>
                   <a:srgbClr val="14161C"/>
                 </a:solidFill>
@@ -12661,7 +12683,7 @@
               <a:t> là</a:t>
             </a:r>
             <a:r>
-              <a:rPr lang="en-US" sz="2400" dirty="0" spc="-1" kern="0">
+              <a:rPr lang="en-US" sz="2550" dirty="0" spc="-2" kern="0">
                 <a:solidFill>
                   <a:srgbClr val="14161C"/>
                 </a:solidFill>
@@ -12672,7 +12694,7 @@
               <a:t> 128</a:t>
             </a:r>
             <a:r>
-              <a:rPr lang="en-US" sz="2400" dirty="0" spc="0" kern="0">
+              <a:rPr lang="en-US" sz="2550" dirty="0" spc="1" kern="0">
                 <a:solidFill>
                   <a:srgbClr val="14161C"/>
                 </a:solidFill>
@@ -12683,7 +12705,7 @@
               <a:t> +</a:t>
             </a:r>
             <a:r>
-              <a:rPr lang="en-US" sz="2400" dirty="0" spc="-1" kern="0">
+              <a:rPr lang="en-US" sz="2550" dirty="0" spc="0" kern="0">
                 <a:solidFill>
                   <a:srgbClr val="14161C"/>
                 </a:solidFill>
@@ -12691,10 +12713,10 @@
                 <a:ea typeface="Be Vietnam Pro" pitchFamily="34" charset="-122"/>
                 <a:cs typeface="Be Vietnam Pro" pitchFamily="34" charset="-120"/>
               </a:rPr>
-              <a:t> 9: SIGKILL.</a:t>
-            </a:r>
-            <a:r>
-              <a:rPr lang="en-US" sz="2400" dirty="0" spc="0" kern="0">
+              <a:t> 9:</a:t>
+            </a:r>
+            <a:r>
+              <a:rPr lang="en-US" sz="2550" dirty="0" spc="-2" kern="0">
                 <a:solidFill>
                   <a:srgbClr val="14161C"/>
                 </a:solidFill>
@@ -12702,10 +12724,21 @@
                 <a:ea typeface="Be Vietnam Pro" pitchFamily="34" charset="-122"/>
                 <a:cs typeface="Be Vietnam Pro" pitchFamily="34" charset="-120"/>
               </a:rPr>
+              <a:t> SIGKILL.</a:t>
+            </a:r>
+            <a:r>
+              <a:rPr lang="en-US" sz="2550" dirty="0" spc="2" kern="0">
+                <a:solidFill>
+                  <a:srgbClr val="14161C"/>
+                </a:solidFill>
+                <a:latin typeface="Be Vietnam Pro" pitchFamily="34" charset="0"/>
+                <a:ea typeface="Be Vietnam Pro" pitchFamily="34" charset="-122"/>
+                <a:cs typeface="Be Vietnam Pro" pitchFamily="34" charset="-120"/>
+              </a:rPr>
               <a:t> Chỉ</a:t>
             </a:r>
             <a:r>
-              <a:rPr lang="en-US" sz="2400" dirty="0" spc="2" kern="0">
+              <a:rPr lang="en-US" sz="2550" dirty="0" spc="0" kern="0">
                 <a:solidFill>
                   <a:srgbClr val="14161C"/>
                 </a:solidFill>
@@ -12716,7 +12749,7 @@
               <a:t> là manh</a:t>
             </a:r>
             <a:r>
-              <a:rPr lang="en-US" sz="2400" dirty="0" spc="1" kern="0">
+              <a:rPr lang="en-US" sz="2550" dirty="0" spc="1" kern="0">
                 <a:solidFill>
                   <a:srgbClr val="14161C"/>
                 </a:solidFill>
@@ -12726,7 +12759,7 @@
               </a:rPr>
               <a:t> mối.</a:t>
             </a:r>
-            <a:endParaRPr lang="en-US" sz="2400" dirty="0"/>
+            <a:endParaRPr lang="en-US" sz="2550" dirty="0"/>
           </a:p>
         </p:txBody>
       </p:sp>
@@ -12836,17 +12869,17 @@
           <a:ln/>
         </p:spPr>
         <p:txBody>
-          <a:bodyPr wrap="square" lIns="0" tIns="10001" rIns="0" bIns="-10001" rtlCol="0" anchor="t"/>
+          <a:bodyPr wrap="square" lIns="0" tIns="11335" rIns="0" bIns="-11335" rtlCol="0" anchor="t"/>
           <a:lstStyle/>
           <a:p>
             <a:pPr algn="l" indent="0" marL="0">
               <a:lnSpc>
-                <a:spcPts val="2925"/>
+                <a:spcPts val="3315"/>
               </a:lnSpc>
               <a:buNone/>
             </a:pPr>
             <a:r>
-              <a:rPr lang="en-US" sz="2250" b="1" dirty="0" kern="0">
+              <a:rPr lang="en-US" sz="2550" b="1" dirty="0" spc="5" kern="0">
                 <a:solidFill>
                   <a:srgbClr val="14161C"/>
                 </a:solidFill>
@@ -12856,7 +12889,7 @@
               </a:rPr>
               <a:t>docker inspect: State.OOMKilled</a:t>
             </a:r>
-            <a:endParaRPr lang="en-US" sz="2250" dirty="0"/>
+            <a:endParaRPr lang="en-US" sz="2550" dirty="0"/>
           </a:p>
         </p:txBody>
       </p:sp>
@@ -12944,17 +12977,17 @@
           <a:ln/>
         </p:spPr>
         <p:txBody>
-          <a:bodyPr wrap="square" lIns="0" tIns="12144" rIns="0" bIns="-12144" rtlCol="0" anchor="t"/>
+          <a:bodyPr wrap="square" lIns="0" tIns="13764" rIns="0" bIns="-13764" rtlCol="0" anchor="t"/>
           <a:lstStyle/>
           <a:p>
             <a:pPr algn="l" indent="0" marL="0">
               <a:lnSpc>
-                <a:spcPts val="2925"/>
+                <a:spcPts val="3315"/>
               </a:lnSpc>
               <a:buNone/>
             </a:pPr>
             <a:r>
-              <a:rPr lang="en-US" sz="2250" dirty="0" spc="-52" kern="0">
+              <a:rPr lang="en-US" sz="2550" dirty="0" spc="-58" kern="0">
                 <a:solidFill>
                   <a:srgbClr val="14161C"/>
                 </a:solidFill>
@@ -12965,7 +12998,7 @@
               <a:t>Tăng</a:t>
             </a:r>
             <a:r>
-              <a:rPr lang="en-US" sz="2250" dirty="0" spc="-1" kern="0">
+              <a:rPr lang="en-US" sz="2550" dirty="0" spc="0" kern="0">
                 <a:solidFill>
                   <a:srgbClr val="14161C"/>
                 </a:solidFill>
@@ -12976,7 +13009,7 @@
               <a:t> --memory,</a:t>
             </a:r>
             <a:r>
-              <a:rPr lang="en-US" sz="2250" dirty="0" spc="-9" kern="0">
+              <a:rPr lang="en-US" sz="2550" dirty="0" spc="-9" kern="0">
                 <a:solidFill>
                   <a:srgbClr val="14161C"/>
                 </a:solidFill>
@@ -12987,7 +13020,7 @@
               <a:t> hay</a:t>
             </a:r>
             <a:r>
-              <a:rPr lang="en-US" sz="2250" dirty="0" spc="-3" kern="0">
+              <a:rPr lang="en-US" sz="2550" dirty="0" spc="0" kern="0">
                 <a:solidFill>
                   <a:srgbClr val="14161C"/>
                 </a:solidFill>
@@ -12998,7 +13031,7 @@
               <a:t> giảm</a:t>
             </a:r>
             <a:r>
-              <a:rPr lang="en-US" sz="2250" dirty="0" spc="11" kern="0">
+              <a:rPr lang="en-US" sz="2550" dirty="0" spc="9" kern="0">
                 <a:solidFill>
                   <a:srgbClr val="14161C"/>
                 </a:solidFill>
@@ -13009,7 +13042,7 @@
               <a:t> mức</a:t>
             </a:r>
             <a:r>
-              <a:rPr lang="en-US" sz="2250" dirty="0" spc="3" kern="0">
+              <a:rPr lang="en-US" sz="2550" dirty="0" spc="-1" kern="0">
                 <a:solidFill>
                   <a:srgbClr val="14161C"/>
                 </a:solidFill>
@@ -13017,10 +13050,10 @@
                 <a:ea typeface="Be Vietnam Pro" pitchFamily="34" charset="-122"/>
                 <a:cs typeface="Be Vietnam Pro" pitchFamily="34" charset="-120"/>
               </a:rPr>
-              <a:t> dùng</a:t>
-            </a:r>
-            <a:r>
-              <a:rPr lang="en-US" sz="2250" dirty="0" spc="2" kern="0">
+              <a:t> dùng của</a:t>
+            </a:r>
+            <a:r>
+              <a:rPr lang="en-US" sz="2550" dirty="0" spc="24" kern="0">
                 <a:solidFill>
                   <a:srgbClr val="14161C"/>
                 </a:solidFill>
@@ -13028,10 +13061,10 @@
                 <a:ea typeface="Be Vietnam Pro" pitchFamily="34" charset="-122"/>
                 <a:cs typeface="Be Vietnam Pro" pitchFamily="34" charset="-120"/>
               </a:rPr>
-              <a:t> của</a:t>
-            </a:r>
-            <a:r>
-              <a:rPr lang="en-US" sz="2250" dirty="0" spc="24" kern="0">
+              <a:t> ứng</a:t>
+            </a:r>
+            <a:r>
+              <a:rPr lang="en-US" sz="2550" dirty="0" spc="0" kern="0">
                 <a:solidFill>
                   <a:srgbClr val="14161C"/>
                 </a:solidFill>
@@ -13039,20 +13072,9 @@
                 <a:ea typeface="Be Vietnam Pro" pitchFamily="34" charset="-122"/>
                 <a:cs typeface="Be Vietnam Pro" pitchFamily="34" charset="-120"/>
               </a:rPr>
-              <a:t> ứng</a:t>
-            </a:r>
-            <a:r>
-              <a:rPr lang="en-US" sz="2250" dirty="0" spc="3" kern="0">
-                <a:solidFill>
-                  <a:srgbClr val="14161C"/>
-                </a:solidFill>
-                <a:latin typeface="Be Vietnam Pro" pitchFamily="34" charset="0"/>
-                <a:ea typeface="Be Vietnam Pro" pitchFamily="34" charset="-122"/>
-                <a:cs typeface="Be Vietnam Pro" pitchFamily="34" charset="-120"/>
-              </a:rPr>
               <a:t> dụng.</a:t>
             </a:r>
-            <a:endParaRPr lang="en-US" sz="2250" dirty="0"/>
+            <a:endParaRPr lang="en-US" sz="2550" dirty="0"/>
           </a:p>
         </p:txBody>
       </p:sp>
@@ -13140,17 +13162,17 @@
           <a:ln/>
         </p:spPr>
         <p:txBody>
-          <a:bodyPr wrap="square" lIns="0" tIns="12144" rIns="0" bIns="-12144" rtlCol="0" anchor="t"/>
+          <a:bodyPr wrap="square" lIns="0" tIns="13764" rIns="0" bIns="-13764" rtlCol="0" anchor="t"/>
           <a:lstStyle/>
           <a:p>
             <a:pPr algn="l" indent="0" marL="0">
               <a:lnSpc>
-                <a:spcPts val="2925"/>
+                <a:spcPts val="3315"/>
               </a:lnSpc>
               <a:buNone/>
             </a:pPr>
             <a:r>
-              <a:rPr lang="en-US" sz="2250" dirty="0" spc="-34" kern="0">
+              <a:rPr lang="en-US" sz="2550" dirty="0" spc="-33" kern="0">
                 <a:solidFill>
                   <a:srgbClr val="14161C"/>
                 </a:solidFill>
@@ -13161,7 +13183,7 @@
               <a:t>Xem</a:t>
             </a:r>
             <a:r>
-              <a:rPr lang="en-US" sz="2250" dirty="0" spc="-16" kern="0">
+              <a:rPr lang="en-US" sz="2550" dirty="0" spc="-18" kern="0">
                 <a:solidFill>
                   <a:srgbClr val="14161C"/>
                 </a:solidFill>
@@ -13172,7 +13194,7 @@
               <a:t> docker</a:t>
             </a:r>
             <a:r>
-              <a:rPr lang="en-US" sz="2250" dirty="0" spc="-19" kern="0">
+              <a:rPr lang="en-US" sz="2550" dirty="0" spc="-22" kern="0">
                 <a:solidFill>
                   <a:srgbClr val="14161C"/>
                 </a:solidFill>
@@ -13183,7 +13205,7 @@
               <a:t> events</a:t>
             </a:r>
             <a:r>
-              <a:rPr lang="en-US" sz="2250" dirty="0" spc="-16" kern="0">
+              <a:rPr lang="en-US" sz="2550" dirty="0" spc="-19" kern="0">
                 <a:solidFill>
                   <a:srgbClr val="14161C"/>
                 </a:solidFill>
@@ -13194,7 +13216,7 @@
               <a:t> và</a:t>
             </a:r>
             <a:r>
-              <a:rPr lang="en-US" sz="2250" dirty="0" spc="-9" kern="0">
+              <a:rPr lang="en-US" sz="2550" dirty="0" spc="-9" kern="0">
                 <a:solidFill>
                   <a:srgbClr val="14161C"/>
                 </a:solidFill>
@@ -13205,7 +13227,7 @@
               <a:t> nhật</a:t>
             </a:r>
             <a:r>
-              <a:rPr lang="en-US" sz="2250" dirty="0" spc="1" kern="0">
+              <a:rPr lang="en-US" sz="2550" dirty="0" spc="0" kern="0">
                 <a:solidFill>
                   <a:srgbClr val="14161C"/>
                 </a:solidFill>
@@ -13216,7 +13238,7 @@
               <a:t> ký</a:t>
             </a:r>
             <a:r>
-              <a:rPr lang="en-US" sz="2250" dirty="0" spc="-15" kern="0">
+              <a:rPr lang="en-US" sz="2550" dirty="0" spc="-16" kern="0">
                 <a:solidFill>
                   <a:srgbClr val="14161C"/>
                 </a:solidFill>
@@ -13227,7 +13249,7 @@
               <a:t> kernel</a:t>
             </a:r>
             <a:r>
-              <a:rPr lang="en-US" sz="2250" dirty="0" spc="2" kern="0">
+              <a:rPr lang="en-US" sz="2550" dirty="0" spc="-1" kern="0">
                 <a:solidFill>
                   <a:srgbClr val="14161C"/>
                 </a:solidFill>
@@ -13238,7 +13260,7 @@
               <a:t> của</a:t>
             </a:r>
             <a:r>
-              <a:rPr lang="en-US" sz="2250" dirty="0" spc="-10" kern="0">
+              <a:rPr lang="en-US" sz="2550" dirty="0" spc="-9" kern="0">
                 <a:solidFill>
                   <a:srgbClr val="14161C"/>
                 </a:solidFill>
@@ -13249,7 +13271,7 @@
               <a:t> máy</a:t>
             </a:r>
             <a:r>
-              <a:rPr lang="en-US" sz="2250" dirty="0" spc="4" kern="0">
+              <a:rPr lang="en-US" sz="2550" dirty="0" spc="0" kern="0">
                 <a:solidFill>
                   <a:srgbClr val="14161C"/>
                 </a:solidFill>
@@ -13259,7 +13281,7 @@
               </a:rPr>
               <a:t> chủ.</a:t>
             </a:r>
-            <a:endParaRPr lang="en-US" sz="2250" dirty="0"/>
+            <a:endParaRPr lang="en-US" sz="2550" dirty="0"/>
           </a:p>
         </p:txBody>
       </p:sp>

</xml_diff>

<commit_message>
Slides: sd-13-026 logs step names the container
Co-Authored-By: Claude Opus 5.5 <noreply@anthropic.com>
Claude-Session: https://claude.ai/code/session_01TQmrJYLm4GPgtXpQaEk7ey
</commit_message>
<xml_diff>
--- a/system-design-101/vi/lessons/sd-13-026/slides/sd-13-026.pptx
+++ b/system-design-101/vi/lessons/sd-13-026/slides/sd-13-026.pptx
@@ -7352,7 +7352,7 @@
         <p:spPr>
           <a:xfrm>
             <a:off x="7143750" y="4857750"/>
-            <a:ext cx="4000500" cy="476250"/>
+            <a:ext cx="4381500" cy="476250"/>
           </a:xfrm>
           <a:prstGeom prst="rect">
             <a:avLst/>
@@ -7388,6 +7388,17 @@
                 <a:cs typeface="Be Vietnam Pro" pitchFamily="34" charset="-120"/>
               </a:rPr>
               <a:t> 50</a:t>
+            </a:r>
+            <a:r>
+              <a:rPr lang="en-US" sz="2550" dirty="0" spc="-11" kern="0">
+                <a:solidFill>
+                  <a:srgbClr val="14161C"/>
+                </a:solidFill>
+                <a:latin typeface="Be Vietnam Pro" pitchFamily="34" charset="0"/>
+                <a:ea typeface="Be Vietnam Pro" pitchFamily="34" charset="-122"/>
+                <a:cs typeface="Be Vietnam Pro" pitchFamily="34" charset="-120"/>
+              </a:rPr>
+              <a:t> tên-container</a:t>
             </a:r>
             <a:endParaRPr lang="en-US" sz="2550" dirty="0"/>
           </a:p>

</xml_diff>

<commit_message>
Slides: sd-13-026 on-failure policy without the space
Co-Authored-By: Claude Opus 5.5 <noreply@anthropic.com>
Claude-Session: https://claude.ai/code/session_01TQmrJYLm4GPgtXpQaEk7ey
</commit_message>
<xml_diff>
--- a/system-design-101/vi/lessons/sd-13-026/slides/sd-13-026.pptx
+++ b/system-design-101/vi/lessons/sd-13-026/slides/sd-13-026.pptx
@@ -9964,7 +9964,7 @@
               <a:buNone/>
             </a:pPr>
             <a:r>
-              <a:rPr lang="en-US" sz="2550" b="1" dirty="0" spc="-10" kern="0">
+              <a:rPr lang="en-US" sz="2550" b="1" dirty="0" spc="-8" kern="0">
                 <a:solidFill>
                   <a:srgbClr val="B45309"/>
                 </a:solidFill>
@@ -9972,7 +9972,7 @@
                 <a:ea typeface="Be Vietnam Pro" pitchFamily="34" charset="-122"/>
                 <a:cs typeface="Be Vietnam Pro" pitchFamily="34" charset="-120"/>
               </a:rPr>
-              <a:t>on-failure</a:t>
+              <a:t>on-failure[:số</a:t>
             </a:r>
             <a:r>
               <a:rPr lang="en-US" sz="2550" b="1" dirty="0" spc="-3" kern="0">
@@ -9983,7 +9983,7 @@
                 <a:ea typeface="Be Vietnam Pro" pitchFamily="34" charset="-122"/>
                 <a:cs typeface="Be Vietnam Pro" pitchFamily="34" charset="-120"/>
               </a:rPr>
-              <a:t> [:số lần]</a:t>
+              <a:t> lần]</a:t>
             </a:r>
             <a:endParaRPr lang="en-US" sz="2550" dirty="0"/>
           </a:p>

</xml_diff>